<commit_message>
docs: add UI screenshots + backend code slides to the presentation deck
- New `scripts/capture_screenshots.py` uses Playwright (headless Chromium)
  to capture all 6 UI sections at retina quality.
- New `documents/screenshots/` (6 PNGs, ~1.7 MB total).
- `scripts/build_presentation.py` now produces a 20-slide deck mixing:
    * narrative bullets,
    * 6 frontend screenshot slides with captions,
    * 4 backend code-snippet slides pulled live from src/,
    * metrics table, top-rules slide, run instructions.
- Both presentation.pptx and presentation.pdf regenerated.
- Adds `playwright` to requirements.txt for repeatable deck rebuilds.

Co-authored-by: Cursor <cursoragent@cursor.com>
</commit_message>
<xml_diff>
--- a/documents/presentation.pptx
+++ b/documents/presentation.pptx
@@ -21,6 +21,10 @@
     <p:sldId id="269" r:id="rId20"/>
     <p:sldId id="270" r:id="rId21"/>
     <p:sldId id="271" r:id="rId22"/>
+    <p:sldId id="272" r:id="rId23"/>
+    <p:sldId id="273" r:id="rId24"/>
+    <p:sldId id="274" r:id="rId25"/>
+    <p:sldId id="275" r:id="rId26"/>
   </p:sldIdLst>
   <p:sldSz cx="12191695" cy="6858000" type="screen4x3"/>
   <p:notesSz cx="6858000" cy="9144000"/>
@@ -3150,6 +3154,53 @@
           </a:p>
         </p:txBody>
       </p:sp>
+      <p:sp>
+        <p:nvSpPr>
+          <p:cNvPr id="4" name="TextBox 3"/>
+          <p:cNvSpPr txBox="1"/>
+          <p:nvPr/>
+        </p:nvSpPr>
+        <p:spPr>
+          <a:xfrm>
+            <a:off x="914400" y="3657600"/>
+            <a:ext cx="10515600" cy="2377440"/>
+          </a:xfrm>
+          <a:prstGeom prst="rect">
+            <a:avLst/>
+          </a:prstGeom>
+          <a:noFill/>
+        </p:spPr>
+        <p:txBody>
+          <a:bodyPr wrap="square">
+            <a:spAutoFit/>
+          </a:bodyPr>
+          <a:lstStyle/>
+          <a:p>
+            <a:r>
+              <a:rPr sz="1600"/>
+              <a:t>• Dataset: Home Credit Default Risk (Kaggle)</a:t>
+            </a:r>
+          </a:p>
+          <a:p>
+            <a:r>
+              <a:rPr sz="1600"/>
+              <a:t>• Stack: Python 3.11, LightGBM, SHAP, Streamlit, SQLite, Docker</a:t>
+            </a:r>
+          </a:p>
+          <a:p>
+            <a:r>
+              <a:rPr sz="1600"/>
+              <a:t>• LLM: Multi-provider (OpenAI / Groq / Gemini) + deterministic fallback</a:t>
+            </a:r>
+          </a:p>
+          <a:p>
+            <a:r>
+              <a:rPr sz="1600"/>
+              <a:t>• Author: Ashwani Dhayal</a:t>
+            </a:r>
+          </a:p>
+        </p:txBody>
+      </p:sp>
     </p:spTree>
   </p:cSld>
   <p:clrMapOvr>
@@ -3189,57 +3240,60 @@
                   <a:srgbClr val="1F77B4"/>
                 </a:solidFill>
               </a:rPr>
-              <a:t>Module 6 — Dockerised Deployment</a:t>
-            </a:r>
-          </a:p>
-        </p:txBody>
-      </p:sp>
-      <p:sp>
-        <p:nvSpPr>
-          <p:cNvPr id="3" name="Content Placeholder 2"/>
-          <p:cNvSpPr>
-            <a:spLocks noGrp="1"/>
-          </p:cNvSpPr>
-          <p:nvPr>
-            <p:ph idx="1"/>
-          </p:nvPr>
-        </p:nvSpPr>
-        <p:spPr/>
-        <p:txBody>
-          <a:bodyPr/>
-          <a:lstStyle/>
-          <a:p>
-            <a:r>
-              <a:rPr sz="1800"/>
-              <a:t>One command: docker compose up --build.</a:t>
-            </a:r>
-          </a:p>
-          <a:p>
-            <a:pPr/>
-            <a:r>
-              <a:rPr sz="1800"/>
-              <a:t>Multi-stage Dockerfile (builder + slim runtime, non-root user).</a:t>
-            </a:r>
-          </a:p>
-          <a:p>
-            <a:pPr/>
-            <a:r>
-              <a:rPr sz="1800"/>
-              <a:t>Pre-trains the model at build time; healthcheck on /_stcore/health.</a:t>
-            </a:r>
-          </a:p>
-          <a:p>
-            <a:pPr/>
-            <a:r>
-              <a:rPr sz="1800"/>
-              <a:t>Volumes: data/raw is read-only mount; models/ persisted on host.</a:t>
-            </a:r>
-          </a:p>
-          <a:p>
-            <a:pPr/>
-            <a:r>
-              <a:rPr sz="1800"/>
-              <a:t>.env.example documents every variable; auto-detect picks any LLM key.</a:t>
+              <a:t>UI · Talk-to-Data Chatbot</a:t>
+            </a:r>
+          </a:p>
+        </p:txBody>
+      </p:sp>
+      <p:pic>
+        <p:nvPicPr>
+          <p:cNvPr id="3" name="Picture 2" descr="06_chatbot.png"/>
+          <p:cNvPicPr>
+            <a:picLocks noChangeAspect="1"/>
+          </p:cNvPicPr>
+          <p:nvPr/>
+        </p:nvPicPr>
+        <p:blipFill>
+          <a:blip r:embed="rId2"/>
+          <a:stretch>
+            <a:fillRect/>
+          </a:stretch>
+        </p:blipFill>
+        <p:spPr>
+          <a:xfrm>
+            <a:off x="3081653" y="1463040"/>
+            <a:ext cx="6028389" cy="4480560"/>
+          </a:xfrm>
+          <a:prstGeom prst="rect">
+            <a:avLst/>
+          </a:prstGeom>
+        </p:spPr>
+      </p:pic>
+      <p:sp>
+        <p:nvSpPr>
+          <p:cNvPr id="4" name="TextBox 3"/>
+          <p:cNvSpPr txBox="1"/>
+          <p:nvPr/>
+        </p:nvSpPr>
+        <p:spPr>
+          <a:xfrm>
+            <a:off x="457200" y="5943600"/>
+            <a:ext cx="11277295" cy="822960"/>
+          </a:xfrm>
+          <a:prstGeom prst="rect">
+            <a:avLst/>
+          </a:prstGeom>
+          <a:noFill/>
+        </p:spPr>
+        <p:txBody>
+          <a:bodyPr wrap="square">
+            <a:spAutoFit/>
+          </a:bodyPr>
+          <a:lstStyle/>
+          <a:p>
+            <a:r>
+              <a:rPr sz="1300" i="1"/>
+              <a:t>User asks a plain-English question; the agent emits a safe SELECT, runs it on SQLite, and summarises the rows. The generated SQL is exposed for full transparency. Falls back to a deterministic intent parser when no LLM key is set.</a:t>
             </a:r>
           </a:p>
         </p:txBody>
@@ -3283,71 +3337,344 @@
                   <a:srgbClr val="1F77B4"/>
                 </a:solidFill>
               </a:rPr>
-              <a:t>Prompt Engineering &amp; Hallucination Control</a:t>
-            </a:r>
-          </a:p>
-        </p:txBody>
-      </p:sp>
-      <p:sp>
-        <p:nvSpPr>
-          <p:cNvPr id="3" name="Content Placeholder 2"/>
-          <p:cNvSpPr>
-            <a:spLocks noGrp="1"/>
-          </p:cNvSpPr>
-          <p:nvPr>
-            <p:ph idx="1"/>
-          </p:nvPr>
-        </p:nvSpPr>
-        <p:spPr/>
-        <p:txBody>
-          <a:bodyPr/>
-          <a:lstStyle/>
-          <a:p>
-            <a:r>
-              <a:rPr sz="1800"/>
-              <a:t>JSON-only contract: model emits {"sql": "..."}; we parse deterministically.</a:t>
-            </a:r>
-          </a:p>
-          <a:p>
-            <a:pPr/>
-            <a:r>
-              <a:rPr sz="1800"/>
-              <a:t>Pinned schema with column descriptions reduces guessing.</a:t>
-            </a:r>
-          </a:p>
-          <a:p>
-            <a:pPr/>
-            <a:r>
-              <a:rPr sz="1800"/>
-              <a:t>Few-shot examples are short (4 cases) to keep input tokens low.</a:t>
-            </a:r>
-          </a:p>
-          <a:p>
-            <a:pPr/>
-            <a:r>
-              <a:rPr sz="1800"/>
-              <a:t>Temperature 0; max 256 output tokens.</a:t>
-            </a:r>
-          </a:p>
-          <a:p>
-            <a:pPr/>
-            <a:r>
-              <a:rPr sz="1800"/>
-              <a:t>Static SQL safety: regex + sqlparse validates before execution.</a:t>
-            </a:r>
-          </a:p>
-          <a:p>
-            <a:pPr/>
-            <a:r>
-              <a:rPr sz="1800"/>
-              <a:t>Result-grounded summary prompt forbids invented numbers.</a:t>
-            </a:r>
-          </a:p>
-          <a:p>
-            <a:pPr/>
-            <a:r>
-              <a:rPr sz="1800"/>
-              <a:t>Hard fallback path keeps the demo working when the LLM is unavailable.</a:t>
+              <a:t>Backend · ML Training (src/ml/train.py)</a:t>
+            </a:r>
+          </a:p>
+        </p:txBody>
+      </p:sp>
+      <p:sp>
+        <p:nvSpPr>
+          <p:cNvPr id="3" name="TextBox 2"/>
+          <p:cNvSpPr txBox="1"/>
+          <p:nvPr/>
+        </p:nvSpPr>
+        <p:spPr>
+          <a:xfrm>
+            <a:off x="457200" y="1280160"/>
+            <a:ext cx="11277295" cy="548640"/>
+          </a:xfrm>
+          <a:prstGeom prst="rect">
+            <a:avLst/>
+          </a:prstGeom>
+          <a:noFill/>
+        </p:spPr>
+        <p:txBody>
+          <a:bodyPr wrap="square">
+            <a:spAutoFit/>
+          </a:bodyPr>
+          <a:lstStyle/>
+          <a:p>
+            <a:r>
+              <a:rPr sz="1300" i="1">
+                <a:solidFill>
+                  <a:srgbClr val="555555"/>
+                </a:solidFill>
+              </a:rPr>
+              <a:t>LightGBM with scale_pos_weight for class imbalance, threshold chosen by Youden's J on the validation set.</a:t>
+            </a:r>
+          </a:p>
+        </p:txBody>
+      </p:sp>
+      <p:sp>
+        <p:nvSpPr>
+          <p:cNvPr id="4" name="TextBox 3"/>
+          <p:cNvSpPr txBox="1"/>
+          <p:nvPr/>
+        </p:nvSpPr>
+        <p:spPr>
+          <a:xfrm>
+            <a:off x="457200" y="1828800"/>
+            <a:ext cx="11277295" cy="4754880"/>
+          </a:xfrm>
+          <a:prstGeom prst="rect">
+            <a:avLst/>
+          </a:prstGeom>
+          <a:solidFill>
+            <a:srgbClr val="F6F8FA"/>
+          </a:solidFill>
+        </p:spPr>
+        <p:txBody>
+          <a:bodyPr wrap="square" lIns="101600" rIns="101600" tIns="101600" bIns="101600">
+            <a:spAutoFit/>
+          </a:bodyPr>
+          <a:lstStyle/>
+          <a:p/>
+          <a:p>
+            <a:r>
+              <a:rPr sz="1100">
+                <a:latin typeface="Consolas"/>
+              </a:rPr>
+              <a:t>def train(random_state: int = 42) -&gt; TrainingResult:</a:t>
+            </a:r>
+          </a:p>
+          <a:p>
+            <a:r>
+              <a:rPr sz="1100">
+                <a:latin typeface="Consolas"/>
+              </a:rPr>
+              <a:t>    t0 = time.time()</a:t>
+            </a:r>
+          </a:p>
+          <a:p>
+            <a:r>
+              <a:rPr sz="1100">
+                <a:latin typeface="Consolas"/>
+              </a:rPr>
+              <a:t>    df = load_dataframe()</a:t>
+            </a:r>
+          </a:p>
+          <a:p>
+            <a:r>
+              <a:rPr sz="1100">
+                <a:latin typeface="Consolas"/>
+              </a:rPr>
+              <a:t>    df = add_engineered_features(df)</a:t>
+            </a:r>
+          </a:p>
+          <a:p/>
+          <a:p>
+            <a:r>
+              <a:rPr sz="1100">
+                <a:latin typeface="Consolas"/>
+              </a:rPr>
+              <a:t>    y = df["TARGET"].astype(int).values</a:t>
+            </a:r>
+          </a:p>
+          <a:p>
+            <a:r>
+              <a:rPr sz="1100">
+                <a:latin typeface="Consolas"/>
+              </a:rPr>
+              <a:t>    X = df[feature_columns()].copy()</a:t>
+            </a:r>
+          </a:p>
+          <a:p/>
+          <a:p>
+            <a:r>
+              <a:rPr sz="1100">
+                <a:latin typeface="Consolas"/>
+              </a:rPr>
+              <a:t>    X_train, X_val, y_train, y_val = train_test_split(</a:t>
+            </a:r>
+          </a:p>
+          <a:p>
+            <a:r>
+              <a:rPr sz="1100">
+                <a:latin typeface="Consolas"/>
+              </a:rPr>
+              <a:t>        X, y, test_size=0.20, stratify=y, random_state=random_state</a:t>
+            </a:r>
+          </a:p>
+          <a:p>
+            <a:r>
+              <a:rPr sz="1100">
+                <a:latin typeface="Consolas"/>
+              </a:rPr>
+              <a:t>    )</a:t>
+            </a:r>
+          </a:p>
+          <a:p/>
+          <a:p>
+            <a:r>
+              <a:rPr sz="1100">
+                <a:latin typeface="Consolas"/>
+              </a:rPr>
+              <a:t>    preprocessor = build_preprocessor()</a:t>
+            </a:r>
+          </a:p>
+          <a:p>
+            <a:r>
+              <a:rPr sz="1100">
+                <a:latin typeface="Consolas"/>
+              </a:rPr>
+              <a:t>    pos_weight = float((y_train == 0).sum() / max((y_train == 1).sum(), 1))</a:t>
+            </a:r>
+          </a:p>
+          <a:p/>
+          <a:p>
+            <a:r>
+              <a:rPr sz="1100">
+                <a:latin typeface="Consolas"/>
+              </a:rPr>
+              <a:t>    lgbm = LGBMClassifier(</a:t>
+            </a:r>
+          </a:p>
+          <a:p>
+            <a:r>
+              <a:rPr sz="1100">
+                <a:latin typeface="Consolas"/>
+              </a:rPr>
+              <a:t>        n_estimators=400,</a:t>
+            </a:r>
+          </a:p>
+          <a:p>
+            <a:r>
+              <a:rPr sz="1100">
+                <a:latin typeface="Consolas"/>
+              </a:rPr>
+              <a:t>        learning_rate=0.05,</a:t>
+            </a:r>
+          </a:p>
+          <a:p>
+            <a:r>
+              <a:rPr sz="1100">
+                <a:latin typeface="Consolas"/>
+              </a:rPr>
+              <a:t>        num_leaves=31,</a:t>
+            </a:r>
+          </a:p>
+          <a:p>
+            <a:r>
+              <a:rPr sz="1100">
+                <a:latin typeface="Consolas"/>
+              </a:rPr>
+              <a:t>        max_depth=-1,</a:t>
+            </a:r>
+          </a:p>
+          <a:p>
+            <a:r>
+              <a:rPr sz="1100">
+                <a:latin typeface="Consolas"/>
+              </a:rPr>
+              <a:t>        min_child_samples=40,</a:t>
+            </a:r>
+          </a:p>
+          <a:p>
+            <a:r>
+              <a:rPr sz="1100">
+                <a:latin typeface="Consolas"/>
+              </a:rPr>
+              <a:t>        reg_alpha=0.1,</a:t>
+            </a:r>
+          </a:p>
+          <a:p>
+            <a:r>
+              <a:rPr sz="1100">
+                <a:latin typeface="Consolas"/>
+              </a:rPr>
+              <a:t>        reg_lambda=0.1,</a:t>
+            </a:r>
+          </a:p>
+          <a:p>
+            <a:r>
+              <a:rPr sz="1100">
+                <a:latin typeface="Consolas"/>
+              </a:rPr>
+              <a:t>        subsample=0.85,</a:t>
+            </a:r>
+          </a:p>
+          <a:p>
+            <a:r>
+              <a:rPr sz="1100">
+                <a:latin typeface="Consolas"/>
+              </a:rPr>
+              <a:t>        colsample_bytree=0.85,</a:t>
+            </a:r>
+          </a:p>
+          <a:p>
+            <a:r>
+              <a:rPr sz="1100">
+                <a:latin typeface="Consolas"/>
+              </a:rPr>
+              <a:t>        scale_pos_weight=pos_weight,</a:t>
+            </a:r>
+          </a:p>
+          <a:p>
+            <a:r>
+              <a:rPr sz="1100">
+                <a:latin typeface="Consolas"/>
+              </a:rPr>
+              <a:t>        random_state=random_state,</a:t>
+            </a:r>
+          </a:p>
+          <a:p>
+            <a:r>
+              <a:rPr sz="1100">
+                <a:latin typeface="Consolas"/>
+              </a:rPr>
+              <a:t>        n_jobs=-1,</a:t>
+            </a:r>
+          </a:p>
+          <a:p>
+            <a:r>
+              <a:rPr sz="1100">
+                <a:latin typeface="Consolas"/>
+              </a:rPr>
+              <a:t>        verbose=-1,</a:t>
+            </a:r>
+          </a:p>
+          <a:p>
+            <a:r>
+              <a:rPr sz="1100">
+                <a:latin typeface="Consolas"/>
+              </a:rPr>
+              <a:t>    )</a:t>
+            </a:r>
+          </a:p>
+          <a:p/>
+          <a:p>
+            <a:r>
+              <a:rPr sz="1100">
+                <a:latin typeface="Consolas"/>
+              </a:rPr>
+              <a:t>    pipeline = Pipeline(steps=[</a:t>
+            </a:r>
+          </a:p>
+          <a:p>
+            <a:r>
+              <a:rPr sz="1100">
+                <a:latin typeface="Consolas"/>
+              </a:rPr>
+              <a:t>        ("preprocessor", preprocessor),</a:t>
+            </a:r>
+          </a:p>
+          <a:p>
+            <a:r>
+              <a:rPr sz="1100">
+                <a:latin typeface="Consolas"/>
+              </a:rPr>
+              <a:t>        ("classifier", lgbm),</a:t>
+            </a:r>
+          </a:p>
+          <a:p>
+            <a:r>
+              <a:rPr sz="1100">
+                <a:latin typeface="Consolas"/>
+              </a:rPr>
+              <a:t>    ])</a:t>
+            </a:r>
+          </a:p>
+          <a:p>
+            <a:r>
+              <a:rPr sz="1100">
+                <a:latin typeface="Consolas"/>
+              </a:rPr>
+              <a:t>    pipeline.fit(X_train, y_train)</a:t>
+            </a:r>
+          </a:p>
+          <a:p/>
+          <a:p>
+            <a:r>
+              <a:rPr sz="1100">
+                <a:latin typeface="Consolas"/>
+              </a:rPr>
+              <a:t>    proba_val = pipeline.predict_proba(X_val)[:, 1]</a:t>
+            </a:r>
+          </a:p>
+          <a:p>
+            <a:r>
+              <a:rPr sz="1100">
+                <a:latin typeface="Consolas"/>
+              </a:rPr>
+              <a:t>    auc = float(roc_auc_score(y_val, proba_val))</a:t>
+            </a:r>
+          </a:p>
+          <a:p>
+            <a:r>
+              <a:rPr sz="1100">
+                <a:latin typeface="Consolas"/>
+              </a:rPr>
+              <a:t>    pr_auc = float(average_precision_score(y_val, proba_val))</a:t>
             </a:r>
           </a:p>
         </p:txBody>
@@ -3391,57 +3718,454 @@
                   <a:srgbClr val="1F77B4"/>
                 </a:solidFill>
               </a:rPr>
-              <a:t>Token Optimisation</a:t>
-            </a:r>
-          </a:p>
-        </p:txBody>
-      </p:sp>
-      <p:sp>
-        <p:nvSpPr>
-          <p:cNvPr id="3" name="Content Placeholder 2"/>
-          <p:cNvSpPr>
-            <a:spLocks noGrp="1"/>
-          </p:cNvSpPr>
-          <p:nvPr>
-            <p:ph idx="1"/>
-          </p:nvPr>
-        </p:nvSpPr>
-        <p:spPr/>
-        <p:txBody>
-          <a:bodyPr/>
-          <a:lstStyle/>
-          <a:p>
-            <a:r>
-              <a:rPr sz="1800"/>
-              <a:t>Schema (~25 columns) sent once per turn; no DB introspection round-trip.</a:t>
-            </a:r>
-          </a:p>
-          <a:p>
-            <a:pPr/>
-            <a:r>
-              <a:rPr sz="1800"/>
-              <a:t>Compact column descriptions (1 line each) instead of verbose comments.</a:t>
-            </a:r>
-          </a:p>
-          <a:p>
-            <a:pPr/>
-            <a:r>
-              <a:rPr sz="1800"/>
-              <a:t>Few-shot examples reuse the same column names so the model latches faster.</a:t>
-            </a:r>
-          </a:p>
-          <a:p>
-            <a:pPr/>
-            <a:r>
-              <a:rPr sz="1800"/>
-              <a:t>max_tokens caps output; we expect &lt;50 tokens for most SQL replies.</a:t>
-            </a:r>
-          </a:p>
-          <a:p>
-            <a:pPr/>
-            <a:r>
-              <a:rPr sz="1800"/>
-              <a:t>Summarisation only sees the result rows we actually return (≤20).</a:t>
+              <a:t>Backend · NL → SQL Agent (src/llm/nl_to_sql.py)</a:t>
+            </a:r>
+          </a:p>
+        </p:txBody>
+      </p:sp>
+      <p:sp>
+        <p:nvSpPr>
+          <p:cNvPr id="3" name="TextBox 2"/>
+          <p:cNvSpPr txBox="1"/>
+          <p:nvPr/>
+        </p:nvSpPr>
+        <p:spPr>
+          <a:xfrm>
+            <a:off x="457200" y="1280160"/>
+            <a:ext cx="11277295" cy="548640"/>
+          </a:xfrm>
+          <a:prstGeom prst="rect">
+            <a:avLst/>
+          </a:prstGeom>
+          <a:noFill/>
+        </p:spPr>
+        <p:txBody>
+          <a:bodyPr wrap="square">
+            <a:spAutoFit/>
+          </a:bodyPr>
+          <a:lstStyle/>
+          <a:p>
+            <a:r>
+              <a:rPr sz="1300" i="1">
+                <a:solidFill>
+                  <a:srgbClr val="555555"/>
+                </a:solidFill>
+              </a:rPr>
+              <a:t>Pipeline: prompt LLM → parse JSON → static safety check → read-only execute → second LLM call grounds the summary in rows.</a:t>
+            </a:r>
+          </a:p>
+        </p:txBody>
+      </p:sp>
+      <p:sp>
+        <p:nvSpPr>
+          <p:cNvPr id="4" name="TextBox 3"/>
+          <p:cNvSpPr txBox="1"/>
+          <p:nvPr/>
+        </p:nvSpPr>
+        <p:spPr>
+          <a:xfrm>
+            <a:off x="457200" y="1828800"/>
+            <a:ext cx="11277295" cy="4754880"/>
+          </a:xfrm>
+          <a:prstGeom prst="rect">
+            <a:avLst/>
+          </a:prstGeom>
+          <a:solidFill>
+            <a:srgbClr val="F6F8FA"/>
+          </a:solidFill>
+        </p:spPr>
+        <p:txBody>
+          <a:bodyPr wrap="square" lIns="101600" rIns="101600" tIns="101600" bIns="101600">
+            <a:spAutoFit/>
+          </a:bodyPr>
+          <a:lstStyle/>
+          <a:p>
+            <a:r>
+              <a:rPr sz="1100">
+                <a:latin typeface="Consolas"/>
+              </a:rPr>
+              <a:t>        col = df.columns[0]</a:t>
+            </a:r>
+          </a:p>
+          <a:p>
+            <a:r>
+              <a:rPr sz="1100">
+                <a:latin typeface="Consolas"/>
+              </a:rPr>
+              <a:t>        val = df.iloc[0, 0]</a:t>
+            </a:r>
+          </a:p>
+          <a:p>
+            <a:r>
+              <a:rPr sz="1100">
+                <a:latin typeface="Consolas"/>
+              </a:rPr>
+              <a:t>        return f"{col.replace('_', ' ').title()}: {val}"</a:t>
+            </a:r>
+          </a:p>
+          <a:p>
+            <a:r>
+              <a:rPr sz="1100">
+                <a:latin typeface="Consolas"/>
+              </a:rPr>
+              <a:t>    return f"Returned {len(df)} row(s). See the table for details."</a:t>
+            </a:r>
+          </a:p>
+          <a:p/>
+          <a:p/>
+          <a:p>
+            <a:r>
+              <a:rPr sz="1100">
+                <a:latin typeface="Consolas"/>
+              </a:rPr>
+              <a:t># ----------------------------- Public API -----------------------------</a:t>
+            </a:r>
+          </a:p>
+          <a:p>
+            <a:r>
+              <a:rPr sz="1100">
+                <a:latin typeface="Consolas"/>
+              </a:rPr>
+              <a:t>def answer(question: str) -&gt; AgentAnswer:</a:t>
+            </a:r>
+          </a:p>
+          <a:p>
+            <a:r>
+              <a:rPr sz="1100">
+                <a:latin typeface="Consolas"/>
+              </a:rPr>
+              <a:t>    schema = get_table_schema()</a:t>
+            </a:r>
+          </a:p>
+          <a:p>
+            <a:r>
+              <a:rPr sz="1100">
+                <a:latin typeface="Consolas"/>
+              </a:rPr>
+              <a:t>    provider = active_provider()</a:t>
+            </a:r>
+          </a:p>
+          <a:p>
+            <a:r>
+              <a:rPr sz="1100">
+                <a:latin typeface="Consolas"/>
+              </a:rPr>
+              <a:t>    used_fallback = provider == "fallback"</a:t>
+            </a:r>
+          </a:p>
+          <a:p>
+            <a:r>
+              <a:rPr sz="1100">
+                <a:latin typeface="Consolas"/>
+              </a:rPr>
+              <a:t>    sql_raw: str</a:t>
+            </a:r>
+          </a:p>
+          <a:p/>
+          <a:p>
+            <a:r>
+              <a:rPr sz="1100">
+                <a:latin typeface="Consolas"/>
+              </a:rPr>
+              <a:t>    if used_fallback:</a:t>
+            </a:r>
+          </a:p>
+          <a:p>
+            <a:r>
+              <a:rPr sz="1100">
+                <a:latin typeface="Consolas"/>
+              </a:rPr>
+              <a:t>        sql_raw = _fallback_sql(question) or (</a:t>
+            </a:r>
+          </a:p>
+          <a:p>
+            <a:r>
+              <a:rPr sz="1100">
+                <a:latin typeface="Consolas"/>
+              </a:rPr>
+              <a:t>            "SELECT 'unanswerable_with_fallback_parser' AS note"</a:t>
+            </a:r>
+          </a:p>
+          <a:p>
+            <a:r>
+              <a:rPr sz="1100">
+                <a:latin typeface="Consolas"/>
+              </a:rPr>
+              <a:t>        )</a:t>
+            </a:r>
+          </a:p>
+          <a:p>
+            <a:r>
+              <a:rPr sz="1100">
+                <a:latin typeface="Consolas"/>
+              </a:rPr>
+              <a:t>    else:</a:t>
+            </a:r>
+          </a:p>
+          <a:p>
+            <a:r>
+              <a:rPr sz="1100">
+                <a:latin typeface="Consolas"/>
+              </a:rPr>
+              <a:t>        try:</a:t>
+            </a:r>
+          </a:p>
+          <a:p>
+            <a:r>
+              <a:rPr sz="1100">
+                <a:latin typeface="Consolas"/>
+              </a:rPr>
+              <a:t>            client = get_client()</a:t>
+            </a:r>
+          </a:p>
+          <a:p>
+            <a:r>
+              <a:rPr sz="1100">
+                <a:latin typeface="Consolas"/>
+              </a:rPr>
+              <a:t>            llm_text = client.chat(build_messages(schema, question))</a:t>
+            </a:r>
+          </a:p>
+          <a:p>
+            <a:r>
+              <a:rPr sz="1100">
+                <a:latin typeface="Consolas"/>
+              </a:rPr>
+              <a:t>            sql_raw = _extract_json_sql(llm_text)</a:t>
+            </a:r>
+          </a:p>
+          <a:p>
+            <a:r>
+              <a:rPr sz="1100">
+                <a:latin typeface="Consolas"/>
+              </a:rPr>
+              <a:t>        except (LLMUnavailable, Exception) as e:</a:t>
+            </a:r>
+          </a:p>
+          <a:p>
+            <a:r>
+              <a:rPr sz="1100">
+                <a:latin typeface="Consolas"/>
+              </a:rPr>
+              <a:t>            # Hard-fall-through to the deterministic parser.</a:t>
+            </a:r>
+          </a:p>
+          <a:p>
+            <a:r>
+              <a:rPr sz="1100">
+                <a:latin typeface="Consolas"/>
+              </a:rPr>
+              <a:t>            used_fallback = True</a:t>
+            </a:r>
+          </a:p>
+          <a:p>
+            <a:r>
+              <a:rPr sz="1100">
+                <a:latin typeface="Consolas"/>
+              </a:rPr>
+              <a:t>            provider = "fallback"</a:t>
+            </a:r>
+          </a:p>
+          <a:p>
+            <a:r>
+              <a:rPr sz="1100">
+                <a:latin typeface="Consolas"/>
+              </a:rPr>
+              <a:t>            sql_raw = _fallback_sql(question) or (</a:t>
+            </a:r>
+          </a:p>
+          <a:p>
+            <a:r>
+              <a:rPr sz="1100">
+                <a:latin typeface="Consolas"/>
+              </a:rPr>
+              <a:t>                "SELECT 'llm_failed_and_no_fallback_match' AS note"</a:t>
+            </a:r>
+          </a:p>
+          <a:p>
+            <a:r>
+              <a:rPr sz="1100">
+                <a:latin typeface="Consolas"/>
+              </a:rPr>
+              <a:t>            )</a:t>
+            </a:r>
+          </a:p>
+          <a:p/>
+          <a:p>
+            <a:r>
+              <a:rPr sz="1100">
+                <a:latin typeface="Consolas"/>
+              </a:rPr>
+              <a:t>    validation = validate_and_harden(sql_raw)</a:t>
+            </a:r>
+          </a:p>
+          <a:p>
+            <a:r>
+              <a:rPr sz="1100">
+                <a:latin typeface="Consolas"/>
+              </a:rPr>
+              <a:t>    if not validation.ok:</a:t>
+            </a:r>
+          </a:p>
+          <a:p>
+            <a:r>
+              <a:rPr sz="1100">
+                <a:latin typeface="Consolas"/>
+              </a:rPr>
+              <a:t>        return AgentAnswer(</a:t>
+            </a:r>
+          </a:p>
+          <a:p>
+            <a:r>
+              <a:rPr sz="1100">
+                <a:latin typeface="Consolas"/>
+              </a:rPr>
+              <a:t>            question=question,</a:t>
+            </a:r>
+          </a:p>
+          <a:p>
+            <a:r>
+              <a:rPr sz="1100">
+                <a:latin typeface="Consolas"/>
+              </a:rPr>
+              <a:t>            sql=sql_raw,</a:t>
+            </a:r>
+          </a:p>
+          <a:p>
+            <a:r>
+              <a:rPr sz="1100">
+                <a:latin typeface="Consolas"/>
+              </a:rPr>
+              <a:t>            rows=[],</a:t>
+            </a:r>
+          </a:p>
+          <a:p>
+            <a:r>
+              <a:rPr sz="1100">
+                <a:latin typeface="Consolas"/>
+              </a:rPr>
+              <a:t>            answer=f"I rejected the generated SQL: {validation.reason}",</a:t>
+            </a:r>
+          </a:p>
+          <a:p>
+            <a:r>
+              <a:rPr sz="1100">
+                <a:latin typeface="Consolas"/>
+              </a:rPr>
+              <a:t>            provider=provider,</a:t>
+            </a:r>
+          </a:p>
+          <a:p>
+            <a:r>
+              <a:rPr sz="1100">
+                <a:latin typeface="Consolas"/>
+              </a:rPr>
+              <a:t>            used_fallback=used_fallback,</a:t>
+            </a:r>
+          </a:p>
+          <a:p>
+            <a:r>
+              <a:rPr sz="1100">
+                <a:latin typeface="Consolas"/>
+              </a:rPr>
+              <a:t>            error=validation.reason,</a:t>
+            </a:r>
+          </a:p>
+          <a:p>
+            <a:r>
+              <a:rPr sz="1100">
+                <a:latin typeface="Consolas"/>
+              </a:rPr>
+              <a:t>        )</a:t>
+            </a:r>
+          </a:p>
+          <a:p/>
+          <a:p>
+            <a:r>
+              <a:rPr sz="1100">
+                <a:latin typeface="Consolas"/>
+              </a:rPr>
+              <a:t>    try:</a:t>
+            </a:r>
+          </a:p>
+          <a:p>
+            <a:r>
+              <a:rPr sz="1100">
+                <a:latin typeface="Consolas"/>
+              </a:rPr>
+              <a:t>        with open_connection() as conn:</a:t>
+            </a:r>
+          </a:p>
+          <a:p>
+            <a:r>
+              <a:rPr sz="1100">
+                <a:latin typeface="Consolas"/>
+              </a:rPr>
+              <a:t>            df = pd.read_sql_query(validation.sql, conn)</a:t>
+            </a:r>
+          </a:p>
+          <a:p>
+            <a:r>
+              <a:rPr sz="1100">
+                <a:latin typeface="Consolas"/>
+              </a:rPr>
+              <a:t>    except sqlite3.Error as e:</a:t>
+            </a:r>
+          </a:p>
+          <a:p>
+            <a:r>
+              <a:rPr sz="1100">
+                <a:latin typeface="Consolas"/>
+              </a:rPr>
+              <a:t>        return AgentAnswer(</a:t>
+            </a:r>
+          </a:p>
+          <a:p>
+            <a:r>
+              <a:rPr sz="1100">
+                <a:latin typeface="Consolas"/>
+              </a:rPr>
+              <a:t>            question=question,</a:t>
+            </a:r>
+          </a:p>
+          <a:p>
+            <a:r>
+              <a:rPr sz="1100">
+                <a:latin typeface="Consolas"/>
+              </a:rPr>
+              <a:t>            sql=validation.sql,</a:t>
+            </a:r>
+          </a:p>
+          <a:p>
+            <a:r>
+              <a:rPr sz="1100">
+                <a:latin typeface="Consolas"/>
+              </a:rPr>
+              <a:t>            rows=[],</a:t>
+            </a:r>
+          </a:p>
+          <a:p>
+            <a:r>
+              <a:rPr sz="1100">
+                <a:latin typeface="Consolas"/>
+              </a:rPr>
+              <a:t>            answer=f"SQL execution failed: {e}",</a:t>
+            </a:r>
+          </a:p>
+          <a:p>
+            <a:r>
+              <a:rPr sz="1100">
+                <a:latin typeface="Consolas"/>
+              </a:rPr>
+              <a:t>            provider=provider,</a:t>
+            </a:r>
+          </a:p>
+          <a:p>
+            <a:r>
+              <a:rPr sz="1100">
+                <a:latin typeface="Consolas"/>
+              </a:rPr>
+              <a:t>            used_fallback=used_fallback,</a:t>
             </a:r>
           </a:p>
         </p:txBody>
@@ -3485,7 +4209,1041 @@
                   <a:srgbClr val="1F77B4"/>
                 </a:solidFill>
               </a:rPr>
-              <a:t>Evaluation Results</a:t>
+              <a:t>Backend · SQL Safety (src/utils/sql_safety.py)</a:t>
+            </a:r>
+          </a:p>
+        </p:txBody>
+      </p:sp>
+      <p:sp>
+        <p:nvSpPr>
+          <p:cNvPr id="3" name="TextBox 2"/>
+          <p:cNvSpPr txBox="1"/>
+          <p:nvPr/>
+        </p:nvSpPr>
+        <p:spPr>
+          <a:xfrm>
+            <a:off x="457200" y="1280160"/>
+            <a:ext cx="11277295" cy="548640"/>
+          </a:xfrm>
+          <a:prstGeom prst="rect">
+            <a:avLst/>
+          </a:prstGeom>
+          <a:noFill/>
+        </p:spPr>
+        <p:txBody>
+          <a:bodyPr wrap="square">
+            <a:spAutoFit/>
+          </a:bodyPr>
+          <a:lstStyle/>
+          <a:p>
+            <a:r>
+              <a:rPr sz="1300" i="1">
+                <a:solidFill>
+                  <a:srgbClr val="555555"/>
+                </a:solidFill>
+              </a:rPr>
+              <a:t>Single SELECT, table allowlist, blocked keyword list, automatic LIMIT cap. The chatbot cannot mutate data even if the LLM goes off-script.</a:t>
+            </a:r>
+          </a:p>
+        </p:txBody>
+      </p:sp>
+      <p:sp>
+        <p:nvSpPr>
+          <p:cNvPr id="4" name="TextBox 3"/>
+          <p:cNvSpPr txBox="1"/>
+          <p:nvPr/>
+        </p:nvSpPr>
+        <p:spPr>
+          <a:xfrm>
+            <a:off x="457200" y="1828800"/>
+            <a:ext cx="11277295" cy="4754880"/>
+          </a:xfrm>
+          <a:prstGeom prst="rect">
+            <a:avLst/>
+          </a:prstGeom>
+          <a:solidFill>
+            <a:srgbClr val="F6F8FA"/>
+          </a:solidFill>
+        </p:spPr>
+        <p:txBody>
+          <a:bodyPr wrap="square" lIns="101600" rIns="101600" tIns="101600" bIns="101600">
+            <a:spAutoFit/>
+          </a:bodyPr>
+          <a:lstStyle/>
+          <a:p>
+            <a:r>
+              <a:rPr sz="1100">
+                <a:latin typeface="Consolas"/>
+              </a:rPr>
+              <a:t>import sqlparse</a:t>
+            </a:r>
+          </a:p>
+          <a:p/>
+          <a:p>
+            <a:r>
+              <a:rPr sz="1100">
+                <a:latin typeface="Consolas"/>
+              </a:rPr>
+              <a:t>ALLOWED_TABLES = {"applications"}</a:t>
+            </a:r>
+          </a:p>
+          <a:p>
+            <a:r>
+              <a:rPr sz="1100">
+                <a:latin typeface="Consolas"/>
+              </a:rPr>
+              <a:t>FORBIDDEN_PATTERNS = [</a:t>
+            </a:r>
+          </a:p>
+          <a:p>
+            <a:r>
+              <a:rPr sz="1100">
+                <a:latin typeface="Consolas"/>
+              </a:rPr>
+              <a:t>    r"\b(insert|update|delete|drop|alter|create|replace|truncate|grant|revoke)\b",</a:t>
+            </a:r>
+          </a:p>
+          <a:p>
+            <a:r>
+              <a:rPr sz="1100">
+                <a:latin typeface="Consolas"/>
+              </a:rPr>
+              <a:t>    r"\battach\b",</a:t>
+            </a:r>
+          </a:p>
+          <a:p>
+            <a:r>
+              <a:rPr sz="1100">
+                <a:latin typeface="Consolas"/>
+              </a:rPr>
+              <a:t>    r"\bdetach\b",</a:t>
+            </a:r>
+          </a:p>
+          <a:p>
+            <a:r>
+              <a:rPr sz="1100">
+                <a:latin typeface="Consolas"/>
+              </a:rPr>
+              <a:t>    r"\bpragma\b",</a:t>
+            </a:r>
+          </a:p>
+          <a:p>
+            <a:r>
+              <a:rPr sz="1100">
+                <a:latin typeface="Consolas"/>
+              </a:rPr>
+              <a:t>    r"\bvacuum\b",</a:t>
+            </a:r>
+          </a:p>
+          <a:p>
+            <a:r>
+              <a:rPr sz="1100">
+                <a:latin typeface="Consolas"/>
+              </a:rPr>
+              <a:t>    r"\bload_extension\b",</a:t>
+            </a:r>
+          </a:p>
+          <a:p>
+            <a:r>
+              <a:rPr sz="1100">
+                <a:latin typeface="Consolas"/>
+              </a:rPr>
+              <a:t>    r"\b\.shell\b",</a:t>
+            </a:r>
+          </a:p>
+          <a:p>
+            <a:r>
+              <a:rPr sz="1100">
+                <a:latin typeface="Consolas"/>
+              </a:rPr>
+              <a:t>    r"\b\.system\b",</a:t>
+            </a:r>
+          </a:p>
+          <a:p>
+            <a:r>
+              <a:rPr sz="1100">
+                <a:latin typeface="Consolas"/>
+              </a:rPr>
+              <a:t>]</a:t>
+            </a:r>
+          </a:p>
+          <a:p>
+            <a:r>
+              <a:rPr sz="1100">
+                <a:latin typeface="Consolas"/>
+              </a:rPr>
+              <a:t>MAX_ROWS = 200</a:t>
+            </a:r>
+          </a:p>
+          <a:p/>
+          <a:p/>
+          <a:p>
+            <a:r>
+              <a:rPr sz="1100">
+                <a:latin typeface="Consolas"/>
+              </a:rPr>
+              <a:t>@dataclass</a:t>
+            </a:r>
+          </a:p>
+          <a:p>
+            <a:r>
+              <a:rPr sz="1100">
+                <a:latin typeface="Consolas"/>
+              </a:rPr>
+              <a:t>class SqlValidation:</a:t>
+            </a:r>
+          </a:p>
+          <a:p>
+            <a:r>
+              <a:rPr sz="1100">
+                <a:latin typeface="Consolas"/>
+              </a:rPr>
+              <a:t>    ok: bool</a:t>
+            </a:r>
+          </a:p>
+          <a:p>
+            <a:r>
+              <a:rPr sz="1100">
+                <a:latin typeface="Consolas"/>
+              </a:rPr>
+              <a:t>    sql: str</a:t>
+            </a:r>
+          </a:p>
+          <a:p>
+            <a:r>
+              <a:rPr sz="1100">
+                <a:latin typeface="Consolas"/>
+              </a:rPr>
+              <a:t>    reason: str = ""</a:t>
+            </a:r>
+          </a:p>
+          <a:p/>
+          <a:p/>
+          <a:p>
+            <a:r>
+              <a:rPr sz="1100">
+                <a:latin typeface="Consolas"/>
+              </a:rPr>
+              <a:t>def validate_and_harden(sql: str) -&gt; SqlValidation:</a:t>
+            </a:r>
+          </a:p>
+          <a:p>
+            <a:r>
+              <a:rPr sz="1100">
+                <a:latin typeface="Consolas"/>
+              </a:rPr>
+              <a:t>    raw = sql.strip().rstrip(";").strip()</a:t>
+            </a:r>
+          </a:p>
+          <a:p>
+            <a:r>
+              <a:rPr sz="1100">
+                <a:latin typeface="Consolas"/>
+              </a:rPr>
+              <a:t>    if not raw:</a:t>
+            </a:r>
+          </a:p>
+          <a:p>
+            <a:r>
+              <a:rPr sz="1100">
+                <a:latin typeface="Consolas"/>
+              </a:rPr>
+              <a:t>        return SqlValidation(False, "", "Empty SQL.")</a:t>
+            </a:r>
+          </a:p>
+          <a:p/>
+          <a:p>
+            <a:r>
+              <a:rPr sz="1100">
+                <a:latin typeface="Consolas"/>
+              </a:rPr>
+              <a:t>    if ";" in raw:</a:t>
+            </a:r>
+          </a:p>
+          <a:p>
+            <a:r>
+              <a:rPr sz="1100">
+                <a:latin typeface="Consolas"/>
+              </a:rPr>
+              <a:t>        return SqlValidation(False, raw, "Multiple statements are not allowed.")</a:t>
+            </a:r>
+          </a:p>
+          <a:p/>
+          <a:p>
+            <a:r>
+              <a:rPr sz="1100">
+                <a:latin typeface="Consolas"/>
+              </a:rPr>
+              <a:t>    lowered = raw.lower()</a:t>
+            </a:r>
+          </a:p>
+          <a:p>
+            <a:r>
+              <a:rPr sz="1100">
+                <a:latin typeface="Consolas"/>
+              </a:rPr>
+              <a:t>    for pat in FORBIDDEN_PATTERNS:</a:t>
+            </a:r>
+          </a:p>
+          <a:p>
+            <a:r>
+              <a:rPr sz="1100">
+                <a:latin typeface="Consolas"/>
+              </a:rPr>
+              <a:t>        if re.search(pat, lowered):</a:t>
+            </a:r>
+          </a:p>
+          <a:p>
+            <a:r>
+              <a:rPr sz="1100">
+                <a:latin typeface="Consolas"/>
+              </a:rPr>
+              <a:t>            return SqlValidation(False, raw, f"Forbidden keyword detected ({pat}).")</a:t>
+            </a:r>
+          </a:p>
+          <a:p/>
+          <a:p>
+            <a:r>
+              <a:rPr sz="1100">
+                <a:latin typeface="Consolas"/>
+              </a:rPr>
+              <a:t>    parsed = sqlparse.parse(raw)</a:t>
+            </a:r>
+          </a:p>
+          <a:p>
+            <a:r>
+              <a:rPr sz="1100">
+                <a:latin typeface="Consolas"/>
+              </a:rPr>
+              <a:t>    if len(parsed) != 1:</a:t>
+            </a:r>
+          </a:p>
+          <a:p>
+            <a:r>
+              <a:rPr sz="1100">
+                <a:latin typeface="Consolas"/>
+              </a:rPr>
+              <a:t>        return SqlValidation(False, raw, "Exactly one statement is required.")</a:t>
+            </a:r>
+          </a:p>
+          <a:p/>
+          <a:p>
+            <a:r>
+              <a:rPr sz="1100">
+                <a:latin typeface="Consolas"/>
+              </a:rPr>
+              <a:t>    first_token = parsed[0].token_first(skip_ws=True, skip_cm=True)</a:t>
+            </a:r>
+          </a:p>
+          <a:p>
+            <a:r>
+              <a:rPr sz="1100">
+                <a:latin typeface="Consolas"/>
+              </a:rPr>
+              <a:t>    if first_token is None:</a:t>
+            </a:r>
+          </a:p>
+          <a:p>
+            <a:r>
+              <a:rPr sz="1100">
+                <a:latin typeface="Consolas"/>
+              </a:rPr>
+              <a:t>        return SqlValidation(False, raw, "Could not parse SQL.")</a:t>
+            </a:r>
+          </a:p>
+          <a:p/>
+          <a:p>
+            <a:r>
+              <a:rPr sz="1100">
+                <a:latin typeface="Consolas"/>
+              </a:rPr>
+              <a:t>    head = first_token.normalized.upper()</a:t>
+            </a:r>
+          </a:p>
+          <a:p>
+            <a:r>
+              <a:rPr sz="1100">
+                <a:latin typeface="Consolas"/>
+              </a:rPr>
+              <a:t>    if head not in {"SELECT", "WITH"}:</a:t>
+            </a:r>
+          </a:p>
+          <a:p>
+            <a:r>
+              <a:rPr sz="1100">
+                <a:latin typeface="Consolas"/>
+              </a:rPr>
+              <a:t>        return SqlValidation(False, raw, "Only SELECT/WITH queries are permitted.")</a:t>
+            </a:r>
+          </a:p>
+          <a:p/>
+          <a:p>
+            <a:r>
+              <a:rPr sz="1100">
+                <a:latin typeface="Consolas"/>
+              </a:rPr>
+              <a:t>    # Collect CTE aliases (so `WITH t AS (... applications ...)` works).</a:t>
+            </a:r>
+          </a:p>
+          <a:p>
+            <a:r>
+              <a:rPr sz="1100">
+                <a:latin typeface="Consolas"/>
+              </a:rPr>
+              <a:t>    cte_aliases = set(</a:t>
+            </a:r>
+          </a:p>
+          <a:p>
+            <a:r>
+              <a:rPr sz="1100">
+                <a:latin typeface="Consolas"/>
+              </a:rPr>
+              <a:t>        re.findall(r"\b([a-zA-Z_][a-zA-Z0-9_]*)\s+as\s*\(", lowered)</a:t>
+            </a:r>
+          </a:p>
+          <a:p>
+            <a:r>
+              <a:rPr sz="1100">
+                <a:latin typeface="Consolas"/>
+              </a:rPr>
+              <a:t>    )</a:t>
+            </a:r>
+          </a:p>
+          <a:p>
+            <a:r>
+              <a:rPr sz="1100">
+                <a:latin typeface="Consolas"/>
+              </a:rPr>
+              <a:t>    # Reject any reference to unknown tables (cheap heuristic).</a:t>
+            </a:r>
+          </a:p>
+        </p:txBody>
+      </p:sp>
+    </p:spTree>
+  </p:cSld>
+  <p:clrMapOvr>
+    <a:masterClrMapping/>
+  </p:clrMapOvr>
+</p:sld>
+</file>
+
+<file path=ppt/slides/slide14.xml><?xml version="1.0" encoding="utf-8"?>
+<p:sld xmlns:a="http://schemas.openxmlformats.org/drawingml/2006/main" xmlns:p="http://schemas.openxmlformats.org/presentationml/2006/main" xmlns:r="http://schemas.openxmlformats.org/officeDocument/2006/relationships">
+  <p:cSld>
+    <p:spTree>
+      <p:nvGrpSpPr>
+        <p:cNvPr id="1" name=""/>
+        <p:cNvGrpSpPr/>
+        <p:nvPr/>
+      </p:nvGrpSpPr>
+      <p:grpSpPr/>
+      <p:sp>
+        <p:nvSpPr>
+          <p:cNvPr id="2" name="Title 1"/>
+          <p:cNvSpPr>
+            <a:spLocks noGrp="1"/>
+          </p:cNvSpPr>
+          <p:nvPr>
+            <p:ph type="title"/>
+          </p:nvPr>
+        </p:nvSpPr>
+        <p:spPr/>
+        <p:txBody>
+          <a:bodyPr/>
+          <a:lstStyle/>
+          <a:p>
+            <a:r>
+              <a:rPr b="1">
+                <a:solidFill>
+                  <a:srgbClr val="1F77B4"/>
+                </a:solidFill>
+              </a:rPr>
+              <a:t>Backend · Multi-Provider LLM Client (src/llm/client.py)</a:t>
+            </a:r>
+          </a:p>
+        </p:txBody>
+      </p:sp>
+      <p:sp>
+        <p:nvSpPr>
+          <p:cNvPr id="3" name="TextBox 2"/>
+          <p:cNvSpPr txBox="1"/>
+          <p:nvPr/>
+        </p:nvSpPr>
+        <p:spPr>
+          <a:xfrm>
+            <a:off x="457200" y="1280160"/>
+            <a:ext cx="11277295" cy="548640"/>
+          </a:xfrm>
+          <a:prstGeom prst="rect">
+            <a:avLst/>
+          </a:prstGeom>
+          <a:noFill/>
+        </p:spPr>
+        <p:txBody>
+          <a:bodyPr wrap="square">
+            <a:spAutoFit/>
+          </a:bodyPr>
+          <a:lstStyle/>
+          <a:p>
+            <a:r>
+              <a:rPr sz="1300" i="1">
+                <a:solidFill>
+                  <a:srgbClr val="555555"/>
+                </a:solidFill>
+              </a:rPr>
+              <a:t>Auto-detects OpenAI / Groq / Gemini based on whichever API key is set; gracefully falls back to a deterministic parser.</a:t>
+            </a:r>
+          </a:p>
+        </p:txBody>
+      </p:sp>
+      <p:sp>
+        <p:nvSpPr>
+          <p:cNvPr id="4" name="TextBox 3"/>
+          <p:cNvSpPr txBox="1"/>
+          <p:nvPr/>
+        </p:nvSpPr>
+        <p:spPr>
+          <a:xfrm>
+            <a:off x="457200" y="1828800"/>
+            <a:ext cx="11277295" cy="4754880"/>
+          </a:xfrm>
+          <a:prstGeom prst="rect">
+            <a:avLst/>
+          </a:prstGeom>
+          <a:solidFill>
+            <a:srgbClr val="F6F8FA"/>
+          </a:solidFill>
+        </p:spPr>
+        <p:txBody>
+          <a:bodyPr wrap="square" lIns="101600" rIns="101600" tIns="101600" bIns="101600">
+            <a:spAutoFit/>
+          </a:bodyPr>
+          <a:lstStyle/>
+          <a:p>
+            <a:r>
+              <a:rPr sz="1100">
+                <a:latin typeface="Consolas"/>
+              </a:rPr>
+              <a:t>    name: str = "base"</a:t>
+            </a:r>
+          </a:p>
+          <a:p/>
+          <a:p>
+            <a:r>
+              <a:rPr sz="1100">
+                <a:latin typeface="Consolas"/>
+              </a:rPr>
+              <a:t>    def chat(self, messages: list[dict]) -&gt; str:</a:t>
+            </a:r>
+          </a:p>
+          <a:p>
+            <a:r>
+              <a:rPr sz="1100">
+                <a:latin typeface="Consolas"/>
+              </a:rPr>
+              <a:t>        raise NotImplementedError</a:t>
+            </a:r>
+          </a:p>
+          <a:p/>
+          <a:p/>
+          <a:p>
+            <a:r>
+              <a:rPr sz="1100">
+                <a:latin typeface="Consolas"/>
+              </a:rPr>
+              <a:t>class _OpenAIClient(_BaseClient):</a:t>
+            </a:r>
+          </a:p>
+          <a:p>
+            <a:r>
+              <a:rPr sz="1100">
+                <a:latin typeface="Consolas"/>
+              </a:rPr>
+              <a:t>    name = "openai"</a:t>
+            </a:r>
+          </a:p>
+          <a:p/>
+          <a:p>
+            <a:r>
+              <a:rPr sz="1100">
+                <a:latin typeface="Consolas"/>
+              </a:rPr>
+              <a:t>    def __init__(self) -&gt; None:</a:t>
+            </a:r>
+          </a:p>
+          <a:p>
+            <a:r>
+              <a:rPr sz="1100">
+                <a:latin typeface="Consolas"/>
+              </a:rPr>
+              <a:t>        from openai import OpenAI</a:t>
+            </a:r>
+          </a:p>
+          <a:p>
+            <a:r>
+              <a:rPr sz="1100">
+                <a:latin typeface="Consolas"/>
+              </a:rPr>
+              <a:t>        self._client = OpenAI(</a:t>
+            </a:r>
+          </a:p>
+          <a:p>
+            <a:r>
+              <a:rPr sz="1100">
+                <a:latin typeface="Consolas"/>
+              </a:rPr>
+              <a:t>            api_key=SETTINGS.openai_api_key,</a:t>
+            </a:r>
+          </a:p>
+          <a:p>
+            <a:r>
+              <a:rPr sz="1100">
+                <a:latin typeface="Consolas"/>
+              </a:rPr>
+              <a:t>            timeout=SETTINGS.llm_timeout_seconds,</a:t>
+            </a:r>
+          </a:p>
+          <a:p>
+            <a:r>
+              <a:rPr sz="1100">
+                <a:latin typeface="Consolas"/>
+              </a:rPr>
+              <a:t>        )</a:t>
+            </a:r>
+          </a:p>
+          <a:p/>
+          <a:p>
+            <a:r>
+              <a:rPr sz="1100">
+                <a:latin typeface="Consolas"/>
+              </a:rPr>
+              <a:t>    @retry(stop=stop_after_attempt(2), wait=wait_exponential_jitter(initial=1, max=4))</a:t>
+            </a:r>
+          </a:p>
+          <a:p>
+            <a:r>
+              <a:rPr sz="1100">
+                <a:latin typeface="Consolas"/>
+              </a:rPr>
+              <a:t>    def chat(self, messages: list[dict]) -&gt; str:</a:t>
+            </a:r>
+          </a:p>
+          <a:p>
+            <a:r>
+              <a:rPr sz="1100">
+                <a:latin typeface="Consolas"/>
+              </a:rPr>
+              <a:t>        resp = self._client.chat.completions.create(</a:t>
+            </a:r>
+          </a:p>
+          <a:p>
+            <a:r>
+              <a:rPr sz="1100">
+                <a:latin typeface="Consolas"/>
+              </a:rPr>
+              <a:t>            model=SETTINGS.openai_model,</a:t>
+            </a:r>
+          </a:p>
+          <a:p>
+            <a:r>
+              <a:rPr sz="1100">
+                <a:latin typeface="Consolas"/>
+              </a:rPr>
+              <a:t>            messages=messages,</a:t>
+            </a:r>
+          </a:p>
+          <a:p>
+            <a:r>
+              <a:rPr sz="1100">
+                <a:latin typeface="Consolas"/>
+              </a:rPr>
+              <a:t>            temperature=SETTINGS.llm_temperature,</a:t>
+            </a:r>
+          </a:p>
+          <a:p>
+            <a:r>
+              <a:rPr sz="1100">
+                <a:latin typeface="Consolas"/>
+              </a:rPr>
+              <a:t>            max_tokens=SETTINGS.llm_max_tokens,</a:t>
+            </a:r>
+          </a:p>
+          <a:p>
+            <a:r>
+              <a:rPr sz="1100">
+                <a:latin typeface="Consolas"/>
+              </a:rPr>
+              <a:t>        )</a:t>
+            </a:r>
+          </a:p>
+          <a:p>
+            <a:r>
+              <a:rPr sz="1100">
+                <a:latin typeface="Consolas"/>
+              </a:rPr>
+              <a:t>        return (resp.choices[0].message.content or "").strip()</a:t>
+            </a:r>
+          </a:p>
+          <a:p/>
+          <a:p/>
+          <a:p>
+            <a:r>
+              <a:rPr sz="1100">
+                <a:latin typeface="Consolas"/>
+              </a:rPr>
+              <a:t>class _GroqClient(_BaseClient):</a:t>
+            </a:r>
+          </a:p>
+          <a:p>
+            <a:r>
+              <a:rPr sz="1100">
+                <a:latin typeface="Consolas"/>
+              </a:rPr>
+              <a:t>    name = "groq"</a:t>
+            </a:r>
+          </a:p>
+          <a:p/>
+          <a:p>
+            <a:r>
+              <a:rPr sz="1100">
+                <a:latin typeface="Consolas"/>
+              </a:rPr>
+              <a:t>    def __init__(self) -&gt; None:</a:t>
+            </a:r>
+          </a:p>
+          <a:p>
+            <a:r>
+              <a:rPr sz="1100">
+                <a:latin typeface="Consolas"/>
+              </a:rPr>
+              <a:t>        from groq import Groq</a:t>
+            </a:r>
+          </a:p>
+          <a:p>
+            <a:r>
+              <a:rPr sz="1100">
+                <a:latin typeface="Consolas"/>
+              </a:rPr>
+              <a:t>        self._client = Groq(</a:t>
+            </a:r>
+          </a:p>
+          <a:p>
+            <a:r>
+              <a:rPr sz="1100">
+                <a:latin typeface="Consolas"/>
+              </a:rPr>
+              <a:t>            api_key=SETTINGS.groq_api_key,</a:t>
+            </a:r>
+          </a:p>
+          <a:p>
+            <a:r>
+              <a:rPr sz="1100">
+                <a:latin typeface="Consolas"/>
+              </a:rPr>
+              <a:t>            timeout=SETTINGS.llm_timeout_seconds,</a:t>
+            </a:r>
+          </a:p>
+          <a:p>
+            <a:r>
+              <a:rPr sz="1100">
+                <a:latin typeface="Consolas"/>
+              </a:rPr>
+              <a:t>        )</a:t>
+            </a:r>
+          </a:p>
+          <a:p/>
+          <a:p>
+            <a:r>
+              <a:rPr sz="1100">
+                <a:latin typeface="Consolas"/>
+              </a:rPr>
+              <a:t>    @retry(stop=stop_after_attempt(2), wait=wait_exponential_jitter(initial=1, max=4))</a:t>
+            </a:r>
+          </a:p>
+          <a:p>
+            <a:r>
+              <a:rPr sz="1100">
+                <a:latin typeface="Consolas"/>
+              </a:rPr>
+              <a:t>    def chat(self, messages: list[dict]) -&gt; str:</a:t>
+            </a:r>
+          </a:p>
+          <a:p>
+            <a:r>
+              <a:rPr sz="1100">
+                <a:latin typeface="Consolas"/>
+              </a:rPr>
+              <a:t>        resp = self._client.chat.completions.create(</a:t>
+            </a:r>
+          </a:p>
+          <a:p>
+            <a:r>
+              <a:rPr sz="1100">
+                <a:latin typeface="Consolas"/>
+              </a:rPr>
+              <a:t>            model=SETTINGS.groq_model,</a:t>
+            </a:r>
+          </a:p>
+          <a:p>
+            <a:r>
+              <a:rPr sz="1100">
+                <a:latin typeface="Consolas"/>
+              </a:rPr>
+              <a:t>            messages=messages,</a:t>
+            </a:r>
+          </a:p>
+          <a:p>
+            <a:r>
+              <a:rPr sz="1100">
+                <a:latin typeface="Consolas"/>
+              </a:rPr>
+              <a:t>            temperature=SETTINGS.llm_temperature,</a:t>
+            </a:r>
+          </a:p>
+          <a:p>
+            <a:r>
+              <a:rPr sz="1100">
+                <a:latin typeface="Consolas"/>
+              </a:rPr>
+              <a:t>            max_tokens=SETTINGS.llm_max_tokens,</a:t>
+            </a:r>
+          </a:p>
+          <a:p>
+            <a:r>
+              <a:rPr sz="1100">
+                <a:latin typeface="Consolas"/>
+              </a:rPr>
+              <a:t>        )</a:t>
+            </a:r>
+          </a:p>
+          <a:p>
+            <a:r>
+              <a:rPr sz="1100">
+                <a:latin typeface="Consolas"/>
+              </a:rPr>
+              <a:t>        return (resp.choices[0].message.content or "").strip()</a:t>
+            </a:r>
+          </a:p>
+          <a:p/>
+          <a:p/>
+          <a:p>
+            <a:r>
+              <a:rPr sz="1100">
+                <a:latin typeface="Consolas"/>
+              </a:rPr>
+              <a:t>class _GeminiClient(_BaseClient):</a:t>
+            </a:r>
+          </a:p>
+          <a:p>
+            <a:r>
+              <a:rPr sz="1100">
+                <a:latin typeface="Consolas"/>
+              </a:rPr>
+              <a:t>    name = "gemini"</a:t>
+            </a:r>
+          </a:p>
+          <a:p/>
+          <a:p>
+            <a:r>
+              <a:rPr sz="1100">
+                <a:latin typeface="Consolas"/>
+              </a:rPr>
+              <a:t>    def __init__(self) -&gt; None:</a:t>
+            </a:r>
+          </a:p>
+          <a:p>
+            <a:r>
+              <a:rPr sz="1100">
+                <a:latin typeface="Consolas"/>
+              </a:rPr>
+              <a:t>        import google.generativeai as genai</a:t>
+            </a:r>
+          </a:p>
+          <a:p>
+            <a:r>
+              <a:rPr sz="1100">
+                <a:latin typeface="Consolas"/>
+              </a:rPr>
+              <a:t>        genai.configure(api_key=SETTINGS.gemini_api_key)</a:t>
+            </a:r>
+          </a:p>
+          <a:p>
+            <a:r>
+              <a:rPr sz="1100">
+                <a:latin typeface="Consolas"/>
+              </a:rPr>
+              <a:t>        self._genai = genai</a:t>
+            </a:r>
+          </a:p>
+          <a:p>
+            <a:r>
+              <a:rPr sz="1100">
+                <a:latin typeface="Consolas"/>
+              </a:rPr>
+              <a:t>        self._model = genai.GenerativeModel(SETTINGS.gemini_model)</a:t>
+            </a:r>
+          </a:p>
+          <a:p/>
+          <a:p>
+            <a:r>
+              <a:rPr sz="1100">
+                <a:latin typeface="Consolas"/>
+              </a:rPr>
+              <a:t>    @retry(stop=stop_after_attempt(2), wait=wait_exponential_jitter(initial=1, max=4))</a:t>
+            </a:r>
+          </a:p>
+          <a:p>
+            <a:r>
+              <a:rPr sz="1100">
+                <a:latin typeface="Consolas"/>
+              </a:rPr>
+              <a:t>    def chat(self, messages: list[dict]) -&gt; str:</a:t>
+            </a:r>
+          </a:p>
+        </p:txBody>
+      </p:sp>
+    </p:spTree>
+  </p:cSld>
+  <p:clrMapOvr>
+    <a:masterClrMapping/>
+  </p:clrMapOvr>
+</p:sld>
+</file>
+
+<file path=ppt/slides/slide15.xml><?xml version="1.0" encoding="utf-8"?>
+<p:sld xmlns:a="http://schemas.openxmlformats.org/drawingml/2006/main" xmlns:p="http://schemas.openxmlformats.org/presentationml/2006/main" xmlns:r="http://schemas.openxmlformats.org/officeDocument/2006/relationships">
+  <p:cSld>
+    <p:spTree>
+      <p:nvGrpSpPr>
+        <p:cNvPr id="1" name=""/>
+        <p:cNvGrpSpPr/>
+        <p:nvPr/>
+      </p:nvGrpSpPr>
+      <p:grpSpPr/>
+      <p:sp>
+        <p:nvSpPr>
+          <p:cNvPr id="2" name="Title 1"/>
+          <p:cNvSpPr>
+            <a:spLocks noGrp="1"/>
+          </p:cNvSpPr>
+          <p:nvPr>
+            <p:ph type="title"/>
+          </p:nvPr>
+        </p:nvSpPr>
+        <p:spPr/>
+        <p:txBody>
+          <a:bodyPr/>
+          <a:lstStyle/>
+          <a:p>
+            <a:r>
+              <a:rPr b="1">
+                <a:solidFill>
+                  <a:srgbClr val="1F77B4"/>
+                </a:solidFill>
+              </a:rPr>
+              <a:t>Prompt Engineering &amp; Token Optimisation</a:t>
+            </a:r>
+          </a:p>
+        </p:txBody>
+      </p:sp>
+      <p:sp>
+        <p:nvSpPr>
+          <p:cNvPr id="3" name="Content Placeholder 2"/>
+          <p:cNvSpPr>
+            <a:spLocks noGrp="1"/>
+          </p:cNvSpPr>
+          <p:nvPr>
+            <p:ph idx="1"/>
+          </p:nvPr>
+        </p:nvSpPr>
+        <p:spPr/>
+        <p:txBody>
+          <a:bodyPr wrap="square"/>
+          <a:lstStyle/>
+          <a:p>
+            <a:r>
+              <a:rPr sz="1800"/>
+              <a:t>JSON-only output contract — model emits {"sql": "..."}; deterministic parsing.</a:t>
+            </a:r>
+          </a:p>
+          <a:p>
+            <a:r>
+              <a:rPr sz="1800"/>
+              <a:t>Pinned schema (~25 cols, 1-line descriptions) → no DB introspection round-trip.</a:t>
+            </a:r>
+          </a:p>
+          <a:p>
+            <a:r>
+              <a:rPr sz="1800"/>
+              <a:t>Few-shot kept tiny (4 examples) to anchor style without bloating context.</a:t>
+            </a:r>
+          </a:p>
+          <a:p>
+            <a:r>
+              <a:rPr sz="1800"/>
+              <a:t>Temperature 0; max 256 output tokens — SQL doesn't need prose.</a:t>
+            </a:r>
+          </a:p>
+          <a:p>
+            <a:r>
+              <a:rPr sz="1800"/>
+              <a:t>Static SQL safety: SELECT/WITH only, table allowlist, LIMIT cap, blocked keywords.</a:t>
+            </a:r>
+          </a:p>
+          <a:p>
+            <a:r>
+              <a:rPr sz="1800"/>
+              <a:t>Result-grounded summary prompt explicitly forbids invented numbers.</a:t>
+            </a:r>
+          </a:p>
+          <a:p>
+            <a:r>
+              <a:rPr sz="1800"/>
+              <a:t>Hard fallback: deterministic regex parser keeps the demo working offline.</a:t>
+            </a:r>
+          </a:p>
+        </p:txBody>
+      </p:sp>
+    </p:spTree>
+  </p:cSld>
+  <p:clrMapOvr>
+    <a:masterClrMapping/>
+  </p:clrMapOvr>
+</p:sld>
+</file>
+
+<file path=ppt/slides/slide16.xml><?xml version="1.0" encoding="utf-8"?>
+<p:sld xmlns:a="http://schemas.openxmlformats.org/drawingml/2006/main" xmlns:p="http://schemas.openxmlformats.org/presentationml/2006/main" xmlns:r="http://schemas.openxmlformats.org/officeDocument/2006/relationships">
+  <p:cSld>
+    <p:spTree>
+      <p:nvGrpSpPr>
+        <p:cNvPr id="1" name=""/>
+        <p:cNvGrpSpPr/>
+        <p:nvPr/>
+      </p:nvGrpSpPr>
+      <p:grpSpPr/>
+      <p:sp>
+        <p:nvSpPr>
+          <p:cNvPr id="2" name="Title 1"/>
+          <p:cNvSpPr>
+            <a:spLocks noGrp="1"/>
+          </p:cNvSpPr>
+          <p:nvPr>
+            <p:ph type="title"/>
+          </p:nvPr>
+        </p:nvSpPr>
+        <p:spPr/>
+        <p:txBody>
+          <a:bodyPr/>
+          <a:lstStyle/>
+          <a:p>
+            <a:r>
+              <a:rPr b="1">
+                <a:solidFill>
+                  <a:srgbClr val="1F77B4"/>
+                </a:solidFill>
+              </a:rPr>
+              <a:t>Evaluation Results (bundled 10k sample)</a:t>
             </a:r>
           </a:p>
         </p:txBody>
@@ -3499,8 +5257,8 @@
           <p:nvPr/>
         </p:nvGraphicFramePr>
         <p:xfrm>
-          <a:off x="1828800" y="1463040"/>
-          <a:ext cx="8503920" cy="2926080"/>
+          <a:off x="2286000" y="1554480"/>
+          <a:ext cx="7589520" cy="3291840"/>
         </p:xfrm>
         <a:graphic>
           <a:graphicData uri="http://schemas.openxmlformats.org/drawingml/2006/table">
@@ -3509,10 +5267,10 @@
                 <a:tableStyleId>{5C22544A-7EE6-4342-B048-85BDC9FD1C3A}</a:tableStyleId>
               </a:tblPr>
               <a:tblGrid>
-                <a:gridCol w="4251960"/>
-                <a:gridCol w="4251960"/>
+                <a:gridCol w="3794760"/>
+                <a:gridCol w="3794760"/>
               </a:tblGrid>
-              <a:tr h="365760">
+              <a:tr h="411480">
                 <a:tc>
                   <a:txBody>
                     <a:bodyPr/>
@@ -3540,7 +5298,7 @@
                   <a:tcPr/>
                 </a:tc>
               </a:tr>
-              <a:tr h="365760">
+              <a:tr h="411480">
                 <a:tc>
                   <a:txBody>
                     <a:bodyPr/>
@@ -3568,7 +5326,7 @@
                   <a:tcPr/>
                 </a:tc>
               </a:tr>
-              <a:tr h="365760">
+              <a:tr h="411480">
                 <a:tc>
                   <a:txBody>
                     <a:bodyPr/>
@@ -3596,7 +5354,7 @@
                   <a:tcPr/>
                 </a:tc>
               </a:tr>
-              <a:tr h="365760">
+              <a:tr h="411480">
                 <a:tc>
                   <a:txBody>
                     <a:bodyPr/>
@@ -3624,7 +5382,7 @@
                   <a:tcPr/>
                 </a:tc>
               </a:tr>
-              <a:tr h="365760">
+              <a:tr h="411480">
                 <a:tc>
                   <a:txBody>
                     <a:bodyPr/>
@@ -3652,7 +5410,7 @@
                   <a:tcPr/>
                 </a:tc>
               </a:tr>
-              <a:tr h="365760">
+              <a:tr h="411480">
                 <a:tc>
                   <a:txBody>
                     <a:bodyPr/>
@@ -3680,7 +5438,7 @@
                   <a:tcPr/>
                 </a:tc>
               </a:tr>
-              <a:tr h="365760">
+              <a:tr h="411480">
                 <a:tc>
                   <a:txBody>
                     <a:bodyPr/>
@@ -3708,7 +5466,7 @@
                   <a:tcPr/>
                 </a:tc>
               </a:tr>
-              <a:tr h="365760">
+              <a:tr h="411480">
                 <a:tc>
                   <a:txBody>
                     <a:bodyPr/>
@@ -3748,7 +5506,7 @@
 </p:sld>
 </file>
 
-<file path=ppt/slides/slide14.xml><?xml version="1.0" encoding="utf-8"?>
+<file path=ppt/slides/slide17.xml><?xml version="1.0" encoding="utf-8"?>
 <p:sld xmlns:a="http://schemas.openxmlformats.org/drawingml/2006/main" xmlns:p="http://schemas.openxmlformats.org/presentationml/2006/main" xmlns:r="http://schemas.openxmlformats.org/officeDocument/2006/relationships">
   <p:cSld>
     <p:spTree>
@@ -3779,7 +5537,7 @@
                   <a:srgbClr val="1F77B4"/>
                 </a:solidFill>
               </a:rPr>
-              <a:t>How To Run</a:t>
+              <a:t>Top Derived Decision Rules</a:t>
             </a:r>
           </a:p>
         </p:txBody>
@@ -3796,47 +5554,36 @@
         </p:nvSpPr>
         <p:spPr/>
         <p:txBody>
-          <a:bodyPr/>
+          <a:bodyPr wrap="square"/>
           <a:lstStyle/>
           <a:p>
             <a:r>
               <a:rPr sz="1800"/>
-              <a:t>git clone https://github.com/ashwani-dhayal/credit-risk-platform.git</a:t>
-            </a:r>
-          </a:p>
-          <a:p>
-            <a:pPr/>
+              <a:t>R1 · High · support 11.79% · default rate 66.72% · lift 8.34×</a:t>
+            </a:r>
+          </a:p>
+          <a:p>
             <a:r>
               <a:rPr sz="1800"/>
-              <a:t>cd credit-risk-platform</a:t>
-            </a:r>
-          </a:p>
-          <a:p>
-            <a:pPr/>
+              <a:t>R13 · High · support 6.86% · default rate 88.31% · lift 11.04×</a:t>
+            </a:r>
+          </a:p>
+          <a:p>
             <a:r>
               <a:rPr sz="1800"/>
-              <a:t>cp .env.example .env  # add ONE LLM key (optional)</a:t>
-            </a:r>
-          </a:p>
-          <a:p>
-            <a:pPr/>
+              <a:t>R8 · Medium · support 17.3% · default rate 24.71% · lift 3.09×</a:t>
+            </a:r>
+          </a:p>
+          <a:p>
             <a:r>
               <a:rPr sz="1800"/>
-              <a:t>docker compose up --build</a:t>
-            </a:r>
-          </a:p>
-          <a:p>
-            <a:pPr/>
+              <a:t>R7 · High · support 5.79% · default rate 55.18% · lift 6.9×</a:t>
+            </a:r>
+          </a:p>
+          <a:p>
             <a:r>
               <a:rPr sz="1800"/>
-              <a:t>Open http://localhost:8501</a:t>
-            </a:r>
-          </a:p>
-          <a:p>
-            <a:pPr/>
-            <a:r>
-              <a:rPr sz="1800"/>
-              <a:t>Local mode: python -m venv .venv &amp;&amp; pip install -r requirements.txt; python scripts/train_model.py; streamlit run app/streamlit_app.py</a:t>
+              <a:t>R9 · High · support 2.68% · default rate 79.95% · lift 9.99×</a:t>
             </a:r>
           </a:p>
         </p:txBody>
@@ -3849,7 +5596,7 @@
 </p:sld>
 </file>
 
-<file path=ppt/slides/slide15.xml><?xml version="1.0" encoding="utf-8"?>
+<file path=ppt/slides/slide18.xml><?xml version="1.0" encoding="utf-8"?>
 <p:sld xmlns:a="http://schemas.openxmlformats.org/drawingml/2006/main" xmlns:p="http://schemas.openxmlformats.org/presentationml/2006/main" xmlns:r="http://schemas.openxmlformats.org/officeDocument/2006/relationships">
   <p:cSld>
     <p:spTree>
@@ -3880,7 +5627,7 @@
                   <a:srgbClr val="1F77B4"/>
                 </a:solidFill>
               </a:rPr>
-              <a:t>Limitations &amp; Next Steps</a:t>
+              <a:t>How To Run</a:t>
             </a:r>
           </a:p>
         </p:txBody>
@@ -3897,40 +5644,42 @@
         </p:nvSpPr>
         <p:spPr/>
         <p:txBody>
-          <a:bodyPr/>
+          <a:bodyPr wrap="square"/>
           <a:lstStyle/>
           <a:p>
             <a:r>
               <a:rPr sz="1800"/>
-              <a:t>Only application_train modelled — adding bureau / previous_application feature aggregations should lift AUC by ~0.03 on real Kaggle data.</a:t>
-            </a:r>
-          </a:p>
-          <a:p>
-            <a:pPr/>
+              <a:t>git clone https://github.com/ashwani-dhayal/credit-risk-platform.git</a:t>
+            </a:r>
+          </a:p>
+          <a:p>
             <a:r>
               <a:rPr sz="1800"/>
-              <a:t>No data-drift monitoring yet (Evidently / WhyLogs are obvious next steps).</a:t>
-            </a:r>
-          </a:p>
-          <a:p>
-            <a:pPr/>
+              <a:t>cd credit-risk-platform</a:t>
+            </a:r>
+          </a:p>
+          <a:p>
             <a:r>
               <a:rPr sz="1800"/>
-              <a:t>Single-tenant SQLite — switch to Postgres for multi-user.</a:t>
-            </a:r>
-          </a:p>
-          <a:p>
-            <a:pPr/>
+              <a:t>cp .env.example .env  # add ONE LLM key (optional)</a:t>
+            </a:r>
+          </a:p>
+          <a:p>
             <a:r>
               <a:rPr sz="1800"/>
-              <a:t>No UI auth — put behind a reverse proxy in production.</a:t>
-            </a:r>
-          </a:p>
-          <a:p>
-            <a:pPr/>
+              <a:t>docker compose up --build</a:t>
+            </a:r>
+          </a:p>
+          <a:p>
             <a:r>
               <a:rPr sz="1800"/>
-              <a:t>LLM cost cap is per-call; daily quotas would need Redis-based rate limiting.</a:t>
+              <a:t>→ open http://localhost:8501</a:t>
+            </a:r>
+          </a:p>
+          <a:p>
+            <a:r>
+              <a:rPr sz="1800"/>
+              <a:t>Local: python -m venv .venv ; pip install -r requirements.txt ; python scripts/train_model.py ; streamlit run app/streamlit_app.py</a:t>
             </a:r>
           </a:p>
         </p:txBody>
@@ -3943,7 +5692,7 @@
 </p:sld>
 </file>
 
-<file path=ppt/slides/slide16.xml><?xml version="1.0" encoding="utf-8"?>
+<file path=ppt/slides/slide19.xml><?xml version="1.0" encoding="utf-8"?>
 <p:sld xmlns:a="http://schemas.openxmlformats.org/drawingml/2006/main" xmlns:p="http://schemas.openxmlformats.org/presentationml/2006/main" xmlns:r="http://schemas.openxmlformats.org/officeDocument/2006/relationships">
   <p:cSld>
     <p:spTree>
@@ -3974,7 +5723,7 @@
                   <a:srgbClr val="1F77B4"/>
                 </a:solidFill>
               </a:rPr>
-              <a:t>Thank you</a:t>
+              <a:t>Limitations &amp; Next Steps</a:t>
             </a:r>
           </a:p>
         </p:txBody>
@@ -3991,26 +5740,36 @@
         </p:nvSpPr>
         <p:spPr/>
         <p:txBody>
-          <a:bodyPr/>
+          <a:bodyPr wrap="square"/>
           <a:lstStyle/>
           <a:p>
             <a:r>
               <a:rPr sz="1800"/>
-              <a:t>Repo: https://github.com/ashwani-dhayal/credit-risk-platform</a:t>
-            </a:r>
-          </a:p>
-          <a:p>
-            <a:pPr/>
+              <a:t>Adding bureau / previous_application aggregates would lift AUC ~+0.03.</a:t>
+            </a:r>
+          </a:p>
+          <a:p>
             <a:r>
               <a:rPr sz="1800"/>
-              <a:t>Author: Ashwani Dhayal</a:t>
-            </a:r>
-          </a:p>
-          <a:p>
-            <a:pPr/>
+              <a:t>No data-drift monitoring yet (Evidently / WhyLogs are obvious next steps).</a:t>
+            </a:r>
+          </a:p>
+          <a:p>
             <a:r>
               <a:rPr sz="1800"/>
-              <a:t>Submission for NeoStats AI Engineer assignment.</a:t>
+              <a:t>Single-tenant SQLite — switch to Postgres for multi-user concurrency.</a:t>
+            </a:r>
+          </a:p>
+          <a:p>
+            <a:r>
+              <a:rPr sz="1800"/>
+              <a:t>No UI auth — deploy behind a reverse proxy with auth in production.</a:t>
+            </a:r>
+          </a:p>
+          <a:p>
+            <a:r>
+              <a:rPr sz="1800"/>
+              <a:t>LLM cost cap is per-call only; daily quotas would need Redis-based limiting.</a:t>
             </a:r>
           </a:p>
         </p:txBody>
@@ -4071,7 +5830,7 @@
         </p:nvSpPr>
         <p:spPr/>
         <p:txBody>
-          <a:bodyPr/>
+          <a:bodyPr wrap="square"/>
           <a:lstStyle/>
           <a:p>
             <a:r>
@@ -4080,31 +5839,105 @@
             </a:r>
           </a:p>
           <a:p>
-            <a:pPr/>
             <a:r>
               <a:rPr sz="1800"/>
-              <a:t>Identify high-risk applicants early; automate risk scoring.</a:t>
-            </a:r>
-          </a:p>
-          <a:p>
-            <a:pPr/>
+              <a:t>Identify high-risk applicants early and automate risk scoring.</a:t>
+            </a:r>
+          </a:p>
+          <a:p>
             <a:r>
               <a:rPr sz="1800"/>
               <a:t>Provide auditable, regulator-friendly reasons for every decision.</a:t>
             </a:r>
           </a:p>
           <a:p>
-            <a:pPr/>
             <a:r>
               <a:rPr sz="1800"/>
               <a:t>Let business analysts explore the portfolio in plain English.</a:t>
             </a:r>
           </a:p>
           <a:p>
-            <a:pPr/>
             <a:r>
               <a:rPr sz="1800"/>
               <a:t>Bridge ML insights and credit policy through readable rules.</a:t>
+            </a:r>
+          </a:p>
+        </p:txBody>
+      </p:sp>
+    </p:spTree>
+  </p:cSld>
+  <p:clrMapOvr>
+    <a:masterClrMapping/>
+  </p:clrMapOvr>
+</p:sld>
+</file>
+
+<file path=ppt/slides/slide20.xml><?xml version="1.0" encoding="utf-8"?>
+<p:sld xmlns:a="http://schemas.openxmlformats.org/drawingml/2006/main" xmlns:p="http://schemas.openxmlformats.org/presentationml/2006/main" xmlns:r="http://schemas.openxmlformats.org/officeDocument/2006/relationships">
+  <p:cSld>
+    <p:spTree>
+      <p:nvGrpSpPr>
+        <p:cNvPr id="1" name=""/>
+        <p:cNvGrpSpPr/>
+        <p:nvPr/>
+      </p:nvGrpSpPr>
+      <p:grpSpPr/>
+      <p:sp>
+        <p:nvSpPr>
+          <p:cNvPr id="2" name="Title 1"/>
+          <p:cNvSpPr>
+            <a:spLocks noGrp="1"/>
+          </p:cNvSpPr>
+          <p:nvPr>
+            <p:ph type="title"/>
+          </p:nvPr>
+        </p:nvSpPr>
+        <p:spPr/>
+        <p:txBody>
+          <a:bodyPr/>
+          <a:lstStyle/>
+          <a:p>
+            <a:r>
+              <a:rPr b="1">
+                <a:solidFill>
+                  <a:srgbClr val="1F77B4"/>
+                </a:solidFill>
+              </a:rPr>
+              <a:t>Thank You</a:t>
+            </a:r>
+          </a:p>
+        </p:txBody>
+      </p:sp>
+      <p:sp>
+        <p:nvSpPr>
+          <p:cNvPr id="3" name="Content Placeholder 2"/>
+          <p:cNvSpPr>
+            <a:spLocks noGrp="1"/>
+          </p:cNvSpPr>
+          <p:nvPr>
+            <p:ph idx="1"/>
+          </p:nvPr>
+        </p:nvSpPr>
+        <p:spPr/>
+        <p:txBody>
+          <a:bodyPr wrap="square"/>
+          <a:lstStyle/>
+          <a:p>
+            <a:r>
+              <a:rPr sz="1800"/>
+              <a:t>Repo: https://github.com/ashwani-dhayal/credit-risk-platform</a:t>
+            </a:r>
+          </a:p>
+          <a:p>
+            <a:r>
+              <a:rPr sz="1800"/>
+              <a:t>Author: Ashwani Dhayal</a:t>
+            </a:r>
+          </a:p>
+          <a:p>
+            <a:r>
+              <a:rPr sz="1800"/>
+              <a:t>Submission: NeoStats AI Engineer assignment.</a:t>
             </a:r>
           </a:p>
         </p:txBody>
@@ -4165,7 +5998,7 @@
         </p:nvSpPr>
         <p:spPr/>
         <p:txBody>
-          <a:bodyPr/>
+          <a:bodyPr wrap="square"/>
           <a:lstStyle/>
           <a:p>
             <a:r>
@@ -4174,35 +6007,30 @@
             </a:r>
           </a:p>
           <a:p>
-            <a:pPr/>
             <a:r>
               <a:rPr sz="1800"/>
               <a:t>Single Streamlit UI with 6 sections; one Docker command to run.</a:t>
             </a:r>
           </a:p>
           <a:p>
-            <a:pPr/>
             <a:r>
               <a:rPr sz="1800"/>
               <a:t>ML model returns probability + Low/Medium/High band + Decision.</a:t>
             </a:r>
           </a:p>
           <a:p>
-            <a:pPr/>
             <a:r>
               <a:rPr sz="1800"/>
               <a:t>SHAP TreeExplainer attributes every score to ranked feature drivers.</a:t>
             </a:r>
           </a:p>
           <a:p>
-            <a:pPr/>
             <a:r>
               <a:rPr sz="1800"/>
               <a:t>Talk-to-Data agent translates English to safe, read-only SQLite SQL.</a:t>
             </a:r>
           </a:p>
           <a:p>
-            <a:pPr/>
             <a:r>
               <a:rPr sz="1800"/>
               <a:t>Decision-tree rules give credit officers an audit-ready policy view.</a:t>
@@ -4249,7 +6077,7 @@
                   <a:srgbClr val="1F77B4"/>
                 </a:solidFill>
               </a:rPr>
-              <a:t>Architecture</a:t>
+              <a:t>Architecture (logical view)</a:t>
             </a:r>
           </a:p>
         </p:txBody>
@@ -4266,40 +6094,48 @@
         </p:nvSpPr>
         <p:spPr/>
         <p:txBody>
-          <a:bodyPr/>
+          <a:bodyPr wrap="square"/>
           <a:lstStyle/>
           <a:p>
             <a:r>
               <a:rPr sz="1800"/>
-              <a:t>Streamlit UI → src/ml (LightGBM + SHAP) and src/rules (decision tree).</a:t>
-            </a:r>
-          </a:p>
-          <a:p>
-            <a:pPr/>
+              <a:t>Streamlit UI (app/streamlit_app.py) — multi-section navigation.</a:t>
+            </a:r>
+          </a:p>
+          <a:p>
             <a:r>
               <a:rPr sz="1800"/>
-              <a:t>src/data ingests CSV → SQLite (single source of truth for ML &amp; chatbot).</a:t>
-            </a:r>
-          </a:p>
-          <a:p>
-            <a:pPr/>
+              <a:t>src/ml: LightGBM training / inference / SHAP TreeExplainer.</a:t>
+            </a:r>
+          </a:p>
+          <a:p>
             <a:r>
               <a:rPr sz="1800"/>
-              <a:t>src/llm: provider auto-detect (OpenAI → Groq → Gemini → fallback parser).</a:t>
-            </a:r>
-          </a:p>
-          <a:p>
-            <a:pPr/>
+              <a:t>src/rules: depth-4 decision tree → human-readable IF-THEN rules.</a:t>
+            </a:r>
+          </a:p>
+          <a:p>
             <a:r>
               <a:rPr sz="1800"/>
-              <a:t>src/utils/sql_safety: blocks DDL/DML, single-statement, LIMIT enforced.</a:t>
-            </a:r>
-          </a:p>
-          <a:p>
-            <a:pPr/>
+              <a:t>src/data: schema, sample generator, CSV → SQLite ingestion.</a:t>
+            </a:r>
+          </a:p>
+          <a:p>
             <a:r>
               <a:rPr sz="1800"/>
-              <a:t>Dockerfile pre-trains the model at build time so the app boots ready.</a:t>
+              <a:t>src/llm: OpenAI / Groq / Gemini auto-detect + safe NL→SQL agent.</a:t>
+            </a:r>
+          </a:p>
+          <a:p>
+            <a:r>
+              <a:rPr sz="1800"/>
+              <a:t>src/utils/sql_safety: read-only SELECT guardrails (no DDL/DML).</a:t>
+            </a:r>
+          </a:p>
+          <a:p>
+            <a:r>
+              <a:rPr sz="1800"/>
+              <a:t>Single SQLite DB is the source of truth for ML and the chatbot.</a:t>
             </a:r>
           </a:p>
         </p:txBody>
@@ -4343,57 +6179,60 @@
                   <a:srgbClr val="1F77B4"/>
                 </a:solidFill>
               </a:rPr>
-              <a:t>Module 1 — EDA Insights</a:t>
-            </a:r>
-          </a:p>
-        </p:txBody>
-      </p:sp>
-      <p:sp>
-        <p:nvSpPr>
-          <p:cNvPr id="3" name="Content Placeholder 2"/>
-          <p:cNvSpPr>
-            <a:spLocks noGrp="1"/>
-          </p:cNvSpPr>
-          <p:nvPr>
-            <p:ph idx="1"/>
-          </p:nvPr>
-        </p:nvSpPr>
-        <p:spPr/>
-        <p:txBody>
-          <a:bodyPr/>
-          <a:lstStyle/>
-          <a:p>
-            <a:r>
-              <a:rPr sz="1800"/>
-              <a:t>EXT_SOURCE_* are the strongest single predictors; high scores cut default ~5×.</a:t>
-            </a:r>
-          </a:p>
-          <a:p>
-            <a:pPr/>
-            <a:r>
-              <a:rPr sz="1800"/>
-              <a:t>Credit-to-income ratio matters more than absolute income.</a:t>
-            </a:r>
-          </a:p>
-          <a:p>
-            <a:pPr/>
-            <a:r>
-              <a:rPr sz="1800"/>
-              <a:t>Higher-education / Academic-degree applicants default less.</a:t>
-            </a:r>
-          </a:p>
-          <a:p>
-            <a:pPr/>
-            <a:r>
-              <a:rPr sz="1800"/>
-              <a:t>Younger applicants (≤30y) are riskier; flattens after ~45.</a:t>
-            </a:r>
-          </a:p>
-          <a:p>
-            <a:pPr/>
-            <a:r>
-              <a:rPr sz="1800"/>
-              <a:t>Employment tenure protects; sentinel DAYS_EMPLOYED=365243 must be NaN.</a:t>
+              <a:t>UI · Overview Section</a:t>
+            </a:r>
+          </a:p>
+        </p:txBody>
+      </p:sp>
+      <p:pic>
+        <p:nvPicPr>
+          <p:cNvPr id="3" name="Picture 2" descr="01_overview.png"/>
+          <p:cNvPicPr>
+            <a:picLocks noChangeAspect="1"/>
+          </p:cNvPicPr>
+          <p:nvPr/>
+        </p:nvPicPr>
+        <p:blipFill>
+          <a:blip r:embed="rId2"/>
+          <a:stretch>
+            <a:fillRect/>
+          </a:stretch>
+        </p:blipFill>
+        <p:spPr>
+          <a:xfrm>
+            <a:off x="3081653" y="1463040"/>
+            <a:ext cx="6028389" cy="4480560"/>
+          </a:xfrm>
+          <a:prstGeom prst="rect">
+            <a:avLst/>
+          </a:prstGeom>
+        </p:spPr>
+      </p:pic>
+      <p:sp>
+        <p:nvSpPr>
+          <p:cNvPr id="4" name="TextBox 3"/>
+          <p:cNvSpPr txBox="1"/>
+          <p:nvPr/>
+        </p:nvSpPr>
+        <p:spPr>
+          <a:xfrm>
+            <a:off x="457200" y="5943600"/>
+            <a:ext cx="11277295" cy="822960"/>
+          </a:xfrm>
+          <a:prstGeom prst="rect">
+            <a:avLst/>
+          </a:prstGeom>
+          <a:noFill/>
+        </p:spPr>
+        <p:txBody>
+          <a:bodyPr wrap="square">
+            <a:spAutoFit/>
+          </a:bodyPr>
+          <a:lstStyle/>
+          <a:p>
+            <a:r>
+              <a:rPr sz="1300" i="1"/>
+              <a:t>Live KPIs of the platform: 10,000 applicants, 8% default rate, 28 features after engineering, model ROC-AUC 0.895. The sidebar shows the active LLM provider and the loaded model artifact.</a:t>
             </a:r>
           </a:p>
         </p:txBody>
@@ -4437,57 +6276,60 @@
                   <a:srgbClr val="1F77B4"/>
                 </a:solidFill>
               </a:rPr>
-              <a:t>Module 2 — Talk-to-Data Chatbot</a:t>
-            </a:r>
-          </a:p>
-        </p:txBody>
-      </p:sp>
-      <p:sp>
-        <p:nvSpPr>
-          <p:cNvPr id="3" name="Content Placeholder 2"/>
-          <p:cNvSpPr>
-            <a:spLocks noGrp="1"/>
-          </p:cNvSpPr>
-          <p:nvPr>
-            <p:ph idx="1"/>
-          </p:nvPr>
-        </p:nvSpPr>
-        <p:spPr/>
-        <p:txBody>
-          <a:bodyPr/>
-          <a:lstStyle/>
-          <a:p>
-            <a:r>
-              <a:rPr sz="1800"/>
-              <a:t>Pipeline: NL question → LLM → JSON {sql} → safety guard → run → summarise.</a:t>
-            </a:r>
-          </a:p>
-          <a:p>
-            <a:pPr/>
-            <a:r>
-              <a:rPr sz="1800"/>
-              <a:t>Pinned schema + 4 few-shot examples + temperature=0 + max 256 output tokens.</a:t>
-            </a:r>
-          </a:p>
-          <a:p>
-            <a:pPr/>
-            <a:r>
-              <a:rPr sz="1800"/>
-              <a:t>Static guardrails: SELECT-only, single statement, LIMIT cap, table allowlist.</a:t>
-            </a:r>
-          </a:p>
-          <a:p>
-            <a:pPr/>
-            <a:r>
-              <a:rPr sz="1800"/>
-              <a:t>Read-only SQLite connection (mode=ro) for execution.</a:t>
-            </a:r>
-          </a:p>
-          <a:p>
-            <a:pPr/>
-            <a:r>
-              <a:rPr sz="1800"/>
-              <a:t>Deterministic fallback parser handles 9 canonical questions offline.</a:t>
+              <a:t>UI · Exploratory Data Analysis</a:t>
+            </a:r>
+          </a:p>
+        </p:txBody>
+      </p:sp>
+      <p:pic>
+        <p:nvPicPr>
+          <p:cNvPr id="3" name="Picture 2" descr="02_eda.png"/>
+          <p:cNvPicPr>
+            <a:picLocks noChangeAspect="1"/>
+          </p:cNvPicPr>
+          <p:nvPr/>
+        </p:nvPicPr>
+        <p:blipFill>
+          <a:blip r:embed="rId2"/>
+          <a:stretch>
+            <a:fillRect/>
+          </a:stretch>
+        </p:blipFill>
+        <p:spPr>
+          <a:xfrm>
+            <a:off x="3081653" y="1463040"/>
+            <a:ext cx="6028389" cy="4480560"/>
+          </a:xfrm>
+          <a:prstGeom prst="rect">
+            <a:avLst/>
+          </a:prstGeom>
+        </p:spPr>
+      </p:pic>
+      <p:sp>
+        <p:nvSpPr>
+          <p:cNvPr id="4" name="TextBox 3"/>
+          <p:cNvSpPr txBox="1"/>
+          <p:nvPr/>
+        </p:nvSpPr>
+        <p:spPr>
+          <a:xfrm>
+            <a:off x="457200" y="5943600"/>
+            <a:ext cx="11277295" cy="822960"/>
+          </a:xfrm>
+          <a:prstGeom prst="rect">
+            <a:avLst/>
+          </a:prstGeom>
+          <a:noFill/>
+        </p:spPr>
+        <p:txBody>
+          <a:bodyPr wrap="square">
+            <a:spAutoFit/>
+          </a:bodyPr>
+          <a:lstStyle/>
+          <a:p>
+            <a:r>
+              <a:rPr sz="1300" i="1"/>
+              <a:t>Four EDA tabs: Summary, Demographics, Financials, Default Drivers. Distributions are split by default status; the table on the right shows missingness for the most-affected columns.</a:t>
             </a:r>
           </a:p>
         </p:txBody>
@@ -4531,64 +6373,60 @@
                   <a:srgbClr val="1F77B4"/>
                 </a:solidFill>
               </a:rPr>
-              <a:t>Module 3 — Machine Learning Layer</a:t>
-            </a:r>
-          </a:p>
-        </p:txBody>
-      </p:sp>
-      <p:sp>
-        <p:nvSpPr>
-          <p:cNvPr id="3" name="Content Placeholder 2"/>
-          <p:cNvSpPr>
-            <a:spLocks noGrp="1"/>
-          </p:cNvSpPr>
-          <p:nvPr>
-            <p:ph idx="1"/>
-          </p:nvPr>
-        </p:nvSpPr>
-        <p:spPr/>
-        <p:txBody>
-          <a:bodyPr/>
-          <a:lstStyle/>
-          <a:p>
-            <a:r>
-              <a:rPr sz="1800"/>
-              <a:t>Algorithm: LightGBM • scale_pos_weight handles 8% imbalance.</a:t>
-            </a:r>
-          </a:p>
-          <a:p>
-            <a:pPr/>
-            <a:r>
-              <a:rPr sz="1800"/>
-              <a:t>Validation: 80/20 stratified split.</a:t>
-            </a:r>
-          </a:p>
-          <a:p>
-            <a:pPr/>
-            <a:r>
-              <a:rPr sz="1800"/>
-              <a:t>ROC-AUC: 0.8952 | KS: 0.6571 | PR-AUC: 0.5109</a:t>
-            </a:r>
-          </a:p>
-          <a:p>
-            <a:pPr/>
-            <a:r>
-              <a:rPr sz="1800"/>
-              <a:t>Operating threshold: 0.0631 (Youden's J).</a:t>
-            </a:r>
-          </a:p>
-          <a:p>
-            <a:pPr/>
-            <a:r>
-              <a:rPr sz="1800"/>
-              <a:t>Risk bands: Low &lt;0.20, Medium &lt;0.50, High otherwise.</a:t>
-            </a:r>
-          </a:p>
-          <a:p>
-            <a:pPr/>
-            <a:r>
-              <a:rPr sz="1800"/>
-              <a:t>Decision: Approve / Review / Reject (configurable in .env).</a:t>
+              <a:t>UI · Risk Prediction</a:t>
+            </a:r>
+          </a:p>
+        </p:txBody>
+      </p:sp>
+      <p:pic>
+        <p:nvPicPr>
+          <p:cNvPr id="3" name="Picture 2" descr="03_predict.png"/>
+          <p:cNvPicPr>
+            <a:picLocks noChangeAspect="1"/>
+          </p:cNvPicPr>
+          <p:nvPr/>
+        </p:nvPicPr>
+        <p:blipFill>
+          <a:blip r:embed="rId2"/>
+          <a:stretch>
+            <a:fillRect/>
+          </a:stretch>
+        </p:blipFill>
+        <p:spPr>
+          <a:xfrm>
+            <a:off x="3081653" y="1463040"/>
+            <a:ext cx="6028389" cy="4480560"/>
+          </a:xfrm>
+          <a:prstGeom prst="rect">
+            <a:avLst/>
+          </a:prstGeom>
+        </p:spPr>
+      </p:pic>
+      <p:sp>
+        <p:nvSpPr>
+          <p:cNvPr id="4" name="TextBox 3"/>
+          <p:cNvSpPr txBox="1"/>
+          <p:nvPr/>
+        </p:nvSpPr>
+        <p:spPr>
+          <a:xfrm>
+            <a:off x="457200" y="5943600"/>
+            <a:ext cx="11277295" cy="822960"/>
+          </a:xfrm>
+          <a:prstGeom prst="rect">
+            <a:avLst/>
+          </a:prstGeom>
+          <a:noFill/>
+        </p:spPr>
+        <p:txBody>
+          <a:bodyPr wrap="square">
+            <a:spAutoFit/>
+          </a:bodyPr>
+          <a:lstStyle/>
+          <a:p>
+            <a:r>
+              <a:rPr sz="1300" i="1"/>
+              <a:t>Form-driven applicant scoring. Output: probability of default + risk band (Low / Medium / High) + suggested decision (Approve / Review / Reject). Sample shown: P(default)=0.06% → Low → Approve.</a:t>
             </a:r>
           </a:p>
         </p:txBody>
@@ -4632,50 +6470,60 @@
                   <a:srgbClr val="1F77B4"/>
                 </a:solidFill>
               </a:rPr>
-              <a:t>Module 4 — Explainable AI (SHAP)</a:t>
-            </a:r>
-          </a:p>
-        </p:txBody>
-      </p:sp>
-      <p:sp>
-        <p:nvSpPr>
-          <p:cNvPr id="3" name="Content Placeholder 2"/>
-          <p:cNvSpPr>
-            <a:spLocks noGrp="1"/>
-          </p:cNvSpPr>
-          <p:nvPr>
-            <p:ph idx="1"/>
-          </p:nvPr>
-        </p:nvSpPr>
-        <p:spPr/>
-        <p:txBody>
-          <a:bodyPr/>
-          <a:lstStyle/>
-          <a:p>
-            <a:r>
-              <a:rPr sz="1800"/>
-              <a:t>Per-applicant: top contributors with sign and direction (increases / decreases risk).</a:t>
-            </a:r>
-          </a:p>
-          <a:p>
-            <a:pPr/>
-            <a:r>
-              <a:rPr sz="1800"/>
-              <a:t>Global: mean |SHAP| over a sample of 400 rows.</a:t>
-            </a:r>
-          </a:p>
-          <a:p>
-            <a:pPr/>
-            <a:r>
-              <a:rPr sz="1800"/>
-              <a:t>Exact Shapley values via TreeExplainer — no approximation.</a:t>
-            </a:r>
-          </a:p>
-          <a:p>
-            <a:pPr/>
-            <a:r>
-              <a:rPr sz="1800"/>
-              <a:t>EXT_SOURCE_MEAN, CREDIT_INCOME_RATIO, EXT_SOURCE_2 dominate the global ranking.</a:t>
+              <a:t>UI · Explainability (SHAP)</a:t>
+            </a:r>
+          </a:p>
+        </p:txBody>
+      </p:sp>
+      <p:pic>
+        <p:nvPicPr>
+          <p:cNvPr id="3" name="Picture 2" descr="04_explain.png"/>
+          <p:cNvPicPr>
+            <a:picLocks noChangeAspect="1"/>
+          </p:cNvPicPr>
+          <p:nvPr/>
+        </p:nvPicPr>
+        <p:blipFill>
+          <a:blip r:embed="rId2"/>
+          <a:stretch>
+            <a:fillRect/>
+          </a:stretch>
+        </p:blipFill>
+        <p:spPr>
+          <a:xfrm>
+            <a:off x="3081653" y="1463040"/>
+            <a:ext cx="6028389" cy="4480560"/>
+          </a:xfrm>
+          <a:prstGeom prst="rect">
+            <a:avLst/>
+          </a:prstGeom>
+        </p:spPr>
+      </p:pic>
+      <p:sp>
+        <p:nvSpPr>
+          <p:cNvPr id="4" name="TextBox 3"/>
+          <p:cNvSpPr txBox="1"/>
+          <p:nvPr/>
+        </p:nvSpPr>
+        <p:spPr>
+          <a:xfrm>
+            <a:off x="457200" y="5943600"/>
+            <a:ext cx="11277295" cy="822960"/>
+          </a:xfrm>
+          <a:prstGeom prst="rect">
+            <a:avLst/>
+          </a:prstGeom>
+          <a:noFill/>
+        </p:spPr>
+        <p:txBody>
+          <a:bodyPr wrap="square">
+            <a:spAutoFit/>
+          </a:bodyPr>
+          <a:lstStyle/>
+          <a:p>
+            <a:r>
+              <a:rPr sz="1300" i="1"/>
+              <a:t>Per-applicant top SHAP contributors. Bars going right increase predicted default probability; bars going left decrease it. The table below shows the exact feature values and SHAP magnitudes.</a:t>
             </a:r>
           </a:p>
         </p:txBody>
@@ -4719,78 +6567,60 @@
                   <a:srgbClr val="1F77B4"/>
                 </a:solidFill>
               </a:rPr>
-              <a:t>Module 5 — Decision Rules</a:t>
-            </a:r>
-          </a:p>
-        </p:txBody>
-      </p:sp>
-      <p:sp>
-        <p:nvSpPr>
-          <p:cNvPr id="3" name="Content Placeholder 2"/>
-          <p:cNvSpPr>
-            <a:spLocks noGrp="1"/>
-          </p:cNvSpPr>
-          <p:nvPr>
-            <p:ph idx="1"/>
-          </p:nvPr>
-        </p:nvSpPr>
-        <p:spPr/>
-        <p:txBody>
-          <a:bodyPr/>
-          <a:lstStyle/>
-          <a:p>
-            <a:r>
-              <a:rPr sz="1800"/>
-              <a:t>Depth-4 tree fit on the same engineered features as the model.</a:t>
-            </a:r>
-          </a:p>
-          <a:p>
-            <a:pPr/>
-            <a:r>
-              <a:rPr sz="1800"/>
-              <a:t>Each leaf → IF-THEN rule with support, default-rate, and lift.</a:t>
-            </a:r>
-          </a:p>
-          <a:p>
-            <a:pPr/>
-            <a:r>
-              <a:rPr sz="1800"/>
-              <a:t>Top rules in the bundled run:</a:t>
-            </a:r>
-          </a:p>
-          <a:p>
-            <a:pPr/>
-            <a:r>
-              <a:rPr sz="1800"/>
-              <a:t>R1: High | support 11.79% | default rate 66.72% | lift 8.34×</a:t>
-            </a:r>
-          </a:p>
-          <a:p>
-            <a:pPr/>
-            <a:r>
-              <a:rPr sz="1800"/>
-              <a:t>R13: High | support 6.86% | default rate 88.31% | lift 11.04×</a:t>
-            </a:r>
-          </a:p>
-          <a:p>
-            <a:pPr/>
-            <a:r>
-              <a:rPr sz="1800"/>
-              <a:t>R8: Medium | support 17.3% | default rate 24.71% | lift 3.09×</a:t>
-            </a:r>
-          </a:p>
-          <a:p>
-            <a:pPr/>
-            <a:r>
-              <a:rPr sz="1800"/>
-              <a:t>R7: High | support 5.79% | default rate 55.18% | lift 6.9×</a:t>
-            </a:r>
-          </a:p>
-          <a:p>
-            <a:pPr/>
-            <a:r>
-              <a:rPr sz="1800"/>
-              <a:t>R9: High | support 2.68% | default rate 79.95% | lift 9.99×</a:t>
+              <a:t>UI · Decision Rules</a:t>
+            </a:r>
+          </a:p>
+        </p:txBody>
+      </p:sp>
+      <p:pic>
+        <p:nvPicPr>
+          <p:cNvPr id="3" name="Picture 2" descr="05_rules.png"/>
+          <p:cNvPicPr>
+            <a:picLocks noChangeAspect="1"/>
+          </p:cNvPicPr>
+          <p:nvPr/>
+        </p:nvPicPr>
+        <p:blipFill>
+          <a:blip r:embed="rId2"/>
+          <a:stretch>
+            <a:fillRect/>
+          </a:stretch>
+        </p:blipFill>
+        <p:spPr>
+          <a:xfrm>
+            <a:off x="3081653" y="1463040"/>
+            <a:ext cx="6028389" cy="4480560"/>
+          </a:xfrm>
+          <a:prstGeom prst="rect">
+            <a:avLst/>
+          </a:prstGeom>
+        </p:spPr>
+      </p:pic>
+      <p:sp>
+        <p:nvSpPr>
+          <p:cNvPr id="4" name="TextBox 3"/>
+          <p:cNvSpPr txBox="1"/>
+          <p:nvPr/>
+        </p:nvSpPr>
+        <p:spPr>
+          <a:xfrm>
+            <a:off x="457200" y="5943600"/>
+            <a:ext cx="11277295" cy="822960"/>
+          </a:xfrm>
+          <a:prstGeom prst="rect">
+            <a:avLst/>
+          </a:prstGeom>
+          <a:noFill/>
+        </p:spPr>
+        <p:txBody>
+          <a:bodyPr wrap="square">
+            <a:spAutoFit/>
+          </a:bodyPr>
+          <a:lstStyle/>
+          <a:p>
+            <a:r>
+              <a:rPr sz="1300" i="1"/>
+              <a:t>Business-readable IF-THEN rules derived from a depth-4 decision tree. Each row reports support (% of population), default rate inside the leaf, and lift vs. the 8% base rate.</a:t>
             </a:r>
           </a:p>
         </p:txBody>

</xml_diff>

<commit_message>
refactor: tighten module docstrings and comments; refresh artifacts
- shorten and despecialise module/function docstrings across src/*
- drop 'Design decisions:' / 'Why?' style narrative blocks from code
- consolidate comments to inline 'why' notes only
- update README and SETUP_MAC to a more practical voice
- regenerate model + rules + screenshots + deck against the refactored source

No behavioural change. pytest -q  ->  9 passed.

Co-authored-by: Cursor <cursoragent@cursor.com>
</commit_message>
<xml_diff>
--- a/documents/presentation.pptx
+++ b/documents/presentation.pptx
@@ -3398,37 +3398,133 @@
             <a:spAutoFit/>
           </a:bodyPr>
           <a:lstStyle/>
+          <a:p>
+            <a:r>
+              <a:rPr sz="1100">
+                <a:latin typeface="Consolas"/>
+              </a:rPr>
+              <a:t>    pos_weight = float((y_train == 0).sum() / max((y_train == 1).sum(), 1))</a:t>
+            </a:r>
+          </a:p>
           <a:p/>
           <a:p>
             <a:r>
               <a:rPr sz="1100">
                 <a:latin typeface="Consolas"/>
               </a:rPr>
-              <a:t>def train(random_state: int = 42) -&gt; TrainingResult:</a:t>
-            </a:r>
-          </a:p>
-          <a:p>
-            <a:r>
-              <a:rPr sz="1100">
-                <a:latin typeface="Consolas"/>
-              </a:rPr>
-              <a:t>    t0 = time.time()</a:t>
-            </a:r>
-          </a:p>
-          <a:p>
-            <a:r>
-              <a:rPr sz="1100">
-                <a:latin typeface="Consolas"/>
-              </a:rPr>
-              <a:t>    df = load_dataframe()</a:t>
-            </a:r>
-          </a:p>
-          <a:p>
-            <a:r>
-              <a:rPr sz="1100">
-                <a:latin typeface="Consolas"/>
-              </a:rPr>
-              <a:t>    df = add_engineered_features(df)</a:t>
+              <a:t>    lgbm = LGBMClassifier(</a:t>
+            </a:r>
+          </a:p>
+          <a:p>
+            <a:r>
+              <a:rPr sz="1100">
+                <a:latin typeface="Consolas"/>
+              </a:rPr>
+              <a:t>        n_estimators=400,</a:t>
+            </a:r>
+          </a:p>
+          <a:p>
+            <a:r>
+              <a:rPr sz="1100">
+                <a:latin typeface="Consolas"/>
+              </a:rPr>
+              <a:t>        learning_rate=0.05,</a:t>
+            </a:r>
+          </a:p>
+          <a:p>
+            <a:r>
+              <a:rPr sz="1100">
+                <a:latin typeface="Consolas"/>
+              </a:rPr>
+              <a:t>        num_leaves=31,</a:t>
+            </a:r>
+          </a:p>
+          <a:p>
+            <a:r>
+              <a:rPr sz="1100">
+                <a:latin typeface="Consolas"/>
+              </a:rPr>
+              <a:t>        max_depth=-1,</a:t>
+            </a:r>
+          </a:p>
+          <a:p>
+            <a:r>
+              <a:rPr sz="1100">
+                <a:latin typeface="Consolas"/>
+              </a:rPr>
+              <a:t>        min_child_samples=40,</a:t>
+            </a:r>
+          </a:p>
+          <a:p>
+            <a:r>
+              <a:rPr sz="1100">
+                <a:latin typeface="Consolas"/>
+              </a:rPr>
+              <a:t>        reg_alpha=0.1,</a:t>
+            </a:r>
+          </a:p>
+          <a:p>
+            <a:r>
+              <a:rPr sz="1100">
+                <a:latin typeface="Consolas"/>
+              </a:rPr>
+              <a:t>        reg_lambda=0.1,</a:t>
+            </a:r>
+          </a:p>
+          <a:p>
+            <a:r>
+              <a:rPr sz="1100">
+                <a:latin typeface="Consolas"/>
+              </a:rPr>
+              <a:t>        subsample=0.85,</a:t>
+            </a:r>
+          </a:p>
+          <a:p>
+            <a:r>
+              <a:rPr sz="1100">
+                <a:latin typeface="Consolas"/>
+              </a:rPr>
+              <a:t>        colsample_bytree=0.85,</a:t>
+            </a:r>
+          </a:p>
+          <a:p>
+            <a:r>
+              <a:rPr sz="1100">
+                <a:latin typeface="Consolas"/>
+              </a:rPr>
+              <a:t>        scale_pos_weight=pos_weight,</a:t>
+            </a:r>
+          </a:p>
+          <a:p>
+            <a:r>
+              <a:rPr sz="1100">
+                <a:latin typeface="Consolas"/>
+              </a:rPr>
+              <a:t>        random_state=random_state,</a:t>
+            </a:r>
+          </a:p>
+          <a:p>
+            <a:r>
+              <a:rPr sz="1100">
+                <a:latin typeface="Consolas"/>
+              </a:rPr>
+              <a:t>        n_jobs=-1,</a:t>
+            </a:r>
+          </a:p>
+          <a:p>
+            <a:r>
+              <a:rPr sz="1100">
+                <a:latin typeface="Consolas"/>
+              </a:rPr>
+              <a:t>        verbose=-1,</a:t>
+            </a:r>
+          </a:p>
+          <a:p>
+            <a:r>
+              <a:rPr sz="1100">
+                <a:latin typeface="Consolas"/>
+              </a:rPr>
+              <a:t>    )</a:t>
             </a:r>
           </a:p>
           <a:p/>
@@ -3437,15 +3533,39 @@
               <a:rPr sz="1100">
                 <a:latin typeface="Consolas"/>
               </a:rPr>
-              <a:t>    y = df["TARGET"].astype(int).values</a:t>
-            </a:r>
-          </a:p>
-          <a:p>
-            <a:r>
-              <a:rPr sz="1100">
-                <a:latin typeface="Consolas"/>
-              </a:rPr>
-              <a:t>    X = df[feature_columns()].copy()</a:t>
+              <a:t>    pipeline = Pipeline(steps=[</a:t>
+            </a:r>
+          </a:p>
+          <a:p>
+            <a:r>
+              <a:rPr sz="1100">
+                <a:latin typeface="Consolas"/>
+              </a:rPr>
+              <a:t>        ("preprocessor", preprocessor),</a:t>
+            </a:r>
+          </a:p>
+          <a:p>
+            <a:r>
+              <a:rPr sz="1100">
+                <a:latin typeface="Consolas"/>
+              </a:rPr>
+              <a:t>        ("classifier", lgbm),</a:t>
+            </a:r>
+          </a:p>
+          <a:p>
+            <a:r>
+              <a:rPr sz="1100">
+                <a:latin typeface="Consolas"/>
+              </a:rPr>
+              <a:t>    ])</a:t>
+            </a:r>
+          </a:p>
+          <a:p>
+            <a:r>
+              <a:rPr sz="1100">
+                <a:latin typeface="Consolas"/>
+              </a:rPr>
+              <a:t>    pipeline.fit(X_train, y_train)</a:t>
             </a:r>
           </a:p>
           <a:p/>
@@ -3454,23 +3574,31 @@
               <a:rPr sz="1100">
                 <a:latin typeface="Consolas"/>
               </a:rPr>
-              <a:t>    X_train, X_val, y_train, y_val = train_test_split(</a:t>
-            </a:r>
-          </a:p>
-          <a:p>
-            <a:r>
-              <a:rPr sz="1100">
-                <a:latin typeface="Consolas"/>
-              </a:rPr>
-              <a:t>        X, y, test_size=0.20, stratify=y, random_state=random_state</a:t>
-            </a:r>
-          </a:p>
-          <a:p>
-            <a:r>
-              <a:rPr sz="1100">
-                <a:latin typeface="Consolas"/>
-              </a:rPr>
-              <a:t>    )</a:t>
+              <a:t>    proba_val = pipeline.predict_proba(X_val)[:, 1]</a:t>
+            </a:r>
+          </a:p>
+          <a:p>
+            <a:r>
+              <a:rPr sz="1100">
+                <a:latin typeface="Consolas"/>
+              </a:rPr>
+              <a:t>    auc = float(roc_auc_score(y_val, proba_val))</a:t>
+            </a:r>
+          </a:p>
+          <a:p>
+            <a:r>
+              <a:rPr sz="1100">
+                <a:latin typeface="Consolas"/>
+              </a:rPr>
+              <a:t>    pr_auc = float(average_precision_score(y_val, proba_val))</a:t>
+            </a:r>
+          </a:p>
+          <a:p>
+            <a:r>
+              <a:rPr sz="1100">
+                <a:latin typeface="Consolas"/>
+              </a:rPr>
+              <a:t>    ks = _ks_statistic(y_val, proba_val)</a:t>
             </a:r>
           </a:p>
           <a:p/>
@@ -3479,15 +3607,63 @@
               <a:rPr sz="1100">
                 <a:latin typeface="Consolas"/>
               </a:rPr>
-              <a:t>    preprocessor = build_preprocessor()</a:t>
-            </a:r>
-          </a:p>
-          <a:p>
-            <a:r>
-              <a:rPr sz="1100">
-                <a:latin typeface="Consolas"/>
-              </a:rPr>
-              <a:t>    pos_weight = float((y_train == 0).sum() / max((y_train == 1).sum(), 1))</a:t>
+              <a:t>    # Pick the threshold that maximises Youden's J on the validation set.</a:t>
+            </a:r>
+          </a:p>
+          <a:p>
+            <a:r>
+              <a:rPr sz="1100">
+                <a:latin typeface="Consolas"/>
+              </a:rPr>
+              <a:t>    fpr, tpr, thresholds = roc_curve(y_val, proba_val)</a:t>
+            </a:r>
+          </a:p>
+          <a:p>
+            <a:r>
+              <a:rPr sz="1100">
+                <a:latin typeface="Consolas"/>
+              </a:rPr>
+              <a:t>    j = tpr - fpr</a:t>
+            </a:r>
+          </a:p>
+          <a:p>
+            <a:r>
+              <a:rPr sz="1100">
+                <a:latin typeface="Consolas"/>
+              </a:rPr>
+              <a:t>    best_idx = int(np.argmax(j))</a:t>
+            </a:r>
+          </a:p>
+          <a:p>
+            <a:r>
+              <a:rPr sz="1100">
+                <a:latin typeface="Consolas"/>
+              </a:rPr>
+              <a:t>    best_threshold = float(thresholds[best_idx])</a:t>
+            </a:r>
+          </a:p>
+          <a:p>
+            <a:r>
+              <a:rPr sz="1100">
+                <a:latin typeface="Consolas"/>
+              </a:rPr>
+              <a:t>    preds = (proba_val &gt;= best_threshold).astype(int)</a:t>
+            </a:r>
+          </a:p>
+          <a:p>
+            <a:r>
+              <a:rPr sz="1100">
+                <a:latin typeface="Consolas"/>
+              </a:rPr>
+              <a:t>    f1 = float(f1_score(y_val, preds))</a:t>
+            </a:r>
+          </a:p>
+          <a:p>
+            <a:r>
+              <a:rPr sz="1100">
+                <a:latin typeface="Consolas"/>
+              </a:rPr>
+              <a:t>    cm = confusion_matrix(y_val, preds).tolist()</a:t>
             </a:r>
           </a:p>
           <a:p/>
@@ -3496,185 +3672,23 @@
               <a:rPr sz="1100">
                 <a:latin typeface="Consolas"/>
               </a:rPr>
-              <a:t>    lgbm = LGBMClassifier(</a:t>
-            </a:r>
-          </a:p>
-          <a:p>
-            <a:r>
-              <a:rPr sz="1100">
-                <a:latin typeface="Consolas"/>
-              </a:rPr>
-              <a:t>        n_estimators=400,</a:t>
-            </a:r>
-          </a:p>
-          <a:p>
-            <a:r>
-              <a:rPr sz="1100">
-                <a:latin typeface="Consolas"/>
-              </a:rPr>
-              <a:t>        learning_rate=0.05,</a:t>
-            </a:r>
-          </a:p>
-          <a:p>
-            <a:r>
-              <a:rPr sz="1100">
-                <a:latin typeface="Consolas"/>
-              </a:rPr>
-              <a:t>        num_leaves=31,</a:t>
-            </a:r>
-          </a:p>
-          <a:p>
-            <a:r>
-              <a:rPr sz="1100">
-                <a:latin typeface="Consolas"/>
-              </a:rPr>
-              <a:t>        max_depth=-1,</a:t>
-            </a:r>
-          </a:p>
-          <a:p>
-            <a:r>
-              <a:rPr sz="1100">
-                <a:latin typeface="Consolas"/>
-              </a:rPr>
-              <a:t>        min_child_samples=40,</a:t>
-            </a:r>
-          </a:p>
-          <a:p>
-            <a:r>
-              <a:rPr sz="1100">
-                <a:latin typeface="Consolas"/>
-              </a:rPr>
-              <a:t>        reg_alpha=0.1,</a:t>
-            </a:r>
-          </a:p>
-          <a:p>
-            <a:r>
-              <a:rPr sz="1100">
-                <a:latin typeface="Consolas"/>
-              </a:rPr>
-              <a:t>        reg_lambda=0.1,</a:t>
-            </a:r>
-          </a:p>
-          <a:p>
-            <a:r>
-              <a:rPr sz="1100">
-                <a:latin typeface="Consolas"/>
-              </a:rPr>
-              <a:t>        subsample=0.85,</a:t>
-            </a:r>
-          </a:p>
-          <a:p>
-            <a:r>
-              <a:rPr sz="1100">
-                <a:latin typeface="Consolas"/>
-              </a:rPr>
-              <a:t>        colsample_bytree=0.85,</a:t>
-            </a:r>
-          </a:p>
-          <a:p>
-            <a:r>
-              <a:rPr sz="1100">
-                <a:latin typeface="Consolas"/>
-              </a:rPr>
-              <a:t>        scale_pos_weight=pos_weight,</a:t>
-            </a:r>
-          </a:p>
-          <a:p>
-            <a:r>
-              <a:rPr sz="1100">
-                <a:latin typeface="Consolas"/>
-              </a:rPr>
-              <a:t>        random_state=random_state,</a:t>
-            </a:r>
-          </a:p>
-          <a:p>
-            <a:r>
-              <a:rPr sz="1100">
-                <a:latin typeface="Consolas"/>
-              </a:rPr>
-              <a:t>        n_jobs=-1,</a:t>
-            </a:r>
-          </a:p>
-          <a:p>
-            <a:r>
-              <a:rPr sz="1100">
-                <a:latin typeface="Consolas"/>
-              </a:rPr>
-              <a:t>        verbose=-1,</a:t>
-            </a:r>
-          </a:p>
-          <a:p>
-            <a:r>
-              <a:rPr sz="1100">
-                <a:latin typeface="Consolas"/>
-              </a:rPr>
-              <a:t>    )</a:t>
-            </a:r>
-          </a:p>
-          <a:p/>
-          <a:p>
-            <a:r>
-              <a:rPr sz="1100">
-                <a:latin typeface="Consolas"/>
-              </a:rPr>
-              <a:t>    pipeline = Pipeline(steps=[</a:t>
-            </a:r>
-          </a:p>
-          <a:p>
-            <a:r>
-              <a:rPr sz="1100">
-                <a:latin typeface="Consolas"/>
-              </a:rPr>
-              <a:t>        ("preprocessor", preprocessor),</a:t>
-            </a:r>
-          </a:p>
-          <a:p>
-            <a:r>
-              <a:rPr sz="1100">
-                <a:latin typeface="Consolas"/>
-              </a:rPr>
-              <a:t>        ("classifier", lgbm),</a:t>
-            </a:r>
-          </a:p>
-          <a:p>
-            <a:r>
-              <a:rPr sz="1100">
-                <a:latin typeface="Consolas"/>
-              </a:rPr>
-              <a:t>    ])</a:t>
-            </a:r>
-          </a:p>
-          <a:p>
-            <a:r>
-              <a:rPr sz="1100">
-                <a:latin typeface="Consolas"/>
-              </a:rPr>
-              <a:t>    pipeline.fit(X_train, y_train)</a:t>
-            </a:r>
-          </a:p>
-          <a:p/>
-          <a:p>
-            <a:r>
-              <a:rPr sz="1100">
-                <a:latin typeface="Consolas"/>
-              </a:rPr>
-              <a:t>    proba_val = pipeline.predict_proba(X_val)[:, 1]</a:t>
-            </a:r>
-          </a:p>
-          <a:p>
-            <a:r>
-              <a:rPr sz="1100">
-                <a:latin typeface="Consolas"/>
-              </a:rPr>
-              <a:t>    auc = float(roc_auc_score(y_val, proba_val))</a:t>
-            </a:r>
-          </a:p>
-          <a:p>
-            <a:r>
-              <a:rPr sz="1100">
-                <a:latin typeface="Consolas"/>
-              </a:rPr>
-              <a:t>    pr_auc = float(average_precision_score(y_val, proba_val))</a:t>
+              <a:t>    feat_names = get_feature_names_out(pipeline.named_steps["preprocessor"])</a:t>
+            </a:r>
+          </a:p>
+          <a:p>
+            <a:r>
+              <a:rPr sz="1100">
+                <a:latin typeface="Consolas"/>
+              </a:rPr>
+              <a:t>    importances_arr = pipeline.named_steps["classifier"].feature_importances_</a:t>
+            </a:r>
+          </a:p>
+          <a:p>
+            <a:r>
+              <a:rPr sz="1100">
+                <a:latin typeface="Consolas"/>
+              </a:rPr>
+              <a:t>    importances = dict(</a:t>
             </a:r>
           </a:p>
         </p:txBody>
@@ -3784,81 +3798,313 @@
               <a:rPr sz="1100">
                 <a:latin typeface="Consolas"/>
               </a:rPr>
-              <a:t>        col = df.columns[0]</a:t>
-            </a:r>
-          </a:p>
-          <a:p>
-            <a:r>
-              <a:rPr sz="1100">
-                <a:latin typeface="Consolas"/>
-              </a:rPr>
-              <a:t>        val = df.iloc[0, 0]</a:t>
-            </a:r>
-          </a:p>
-          <a:p>
-            <a:r>
-              <a:rPr sz="1100">
-                <a:latin typeface="Consolas"/>
-              </a:rPr>
-              <a:t>        return f"{col.replace('_', ' ').title()}: {val}"</a:t>
-            </a:r>
-          </a:p>
-          <a:p>
-            <a:r>
-              <a:rPr sz="1100">
-                <a:latin typeface="Consolas"/>
-              </a:rPr>
-              <a:t>    return f"Returned {len(df)} row(s). See the table for details."</a:t>
+              <a:t>        sql_raw = _fallback_sql(question) or (</a:t>
+            </a:r>
+          </a:p>
+          <a:p>
+            <a:r>
+              <a:rPr sz="1100">
+                <a:latin typeface="Consolas"/>
+              </a:rPr>
+              <a:t>            "SELECT 'unanswerable_with_fallback_parser' AS note"</a:t>
+            </a:r>
+          </a:p>
+          <a:p>
+            <a:r>
+              <a:rPr sz="1100">
+                <a:latin typeface="Consolas"/>
+              </a:rPr>
+              <a:t>        )</a:t>
+            </a:r>
+          </a:p>
+          <a:p>
+            <a:r>
+              <a:rPr sz="1100">
+                <a:latin typeface="Consolas"/>
+              </a:rPr>
+              <a:t>    else:</a:t>
+            </a:r>
+          </a:p>
+          <a:p>
+            <a:r>
+              <a:rPr sz="1100">
+                <a:latin typeface="Consolas"/>
+              </a:rPr>
+              <a:t>        try:</a:t>
+            </a:r>
+          </a:p>
+          <a:p>
+            <a:r>
+              <a:rPr sz="1100">
+                <a:latin typeface="Consolas"/>
+              </a:rPr>
+              <a:t>            client = get_client()</a:t>
+            </a:r>
+          </a:p>
+          <a:p>
+            <a:r>
+              <a:rPr sz="1100">
+                <a:latin typeface="Consolas"/>
+              </a:rPr>
+              <a:t>            llm_text = client.chat(build_messages(schema, question))</a:t>
+            </a:r>
+          </a:p>
+          <a:p>
+            <a:r>
+              <a:rPr sz="1100">
+                <a:latin typeface="Consolas"/>
+              </a:rPr>
+              <a:t>            sql_raw = _extract_json_sql(llm_text)</a:t>
+            </a:r>
+          </a:p>
+          <a:p>
+            <a:r>
+              <a:rPr sz="1100">
+                <a:latin typeface="Consolas"/>
+              </a:rPr>
+              <a:t>        except (LLMUnavailable, Exception):</a:t>
+            </a:r>
+          </a:p>
+          <a:p>
+            <a:r>
+              <a:rPr sz="1100">
+                <a:latin typeface="Consolas"/>
+              </a:rPr>
+              <a:t>            # LLM died -- use the deterministic parser instead of giving up.</a:t>
+            </a:r>
+          </a:p>
+          <a:p>
+            <a:r>
+              <a:rPr sz="1100">
+                <a:latin typeface="Consolas"/>
+              </a:rPr>
+              <a:t>            used_fallback = True</a:t>
+            </a:r>
+          </a:p>
+          <a:p>
+            <a:r>
+              <a:rPr sz="1100">
+                <a:latin typeface="Consolas"/>
+              </a:rPr>
+              <a:t>            provider = "fallback"</a:t>
+            </a:r>
+          </a:p>
+          <a:p>
+            <a:r>
+              <a:rPr sz="1100">
+                <a:latin typeface="Consolas"/>
+              </a:rPr>
+              <a:t>            sql_raw = _fallback_sql(question) or (</a:t>
+            </a:r>
+          </a:p>
+          <a:p>
+            <a:r>
+              <a:rPr sz="1100">
+                <a:latin typeface="Consolas"/>
+              </a:rPr>
+              <a:t>                "SELECT 'llm_failed_and_no_fallback_match' AS note"</a:t>
+            </a:r>
+          </a:p>
+          <a:p>
+            <a:r>
+              <a:rPr sz="1100">
+                <a:latin typeface="Consolas"/>
+              </a:rPr>
+              <a:t>            )</a:t>
             </a:r>
           </a:p>
           <a:p/>
+          <a:p>
+            <a:r>
+              <a:rPr sz="1100">
+                <a:latin typeface="Consolas"/>
+              </a:rPr>
+              <a:t>    validation = validate_and_harden(sql_raw)</a:t>
+            </a:r>
+          </a:p>
+          <a:p>
+            <a:r>
+              <a:rPr sz="1100">
+                <a:latin typeface="Consolas"/>
+              </a:rPr>
+              <a:t>    if not validation.ok:</a:t>
+            </a:r>
+          </a:p>
+          <a:p>
+            <a:r>
+              <a:rPr sz="1100">
+                <a:latin typeface="Consolas"/>
+              </a:rPr>
+              <a:t>        return AgentAnswer(</a:t>
+            </a:r>
+          </a:p>
+          <a:p>
+            <a:r>
+              <a:rPr sz="1100">
+                <a:latin typeface="Consolas"/>
+              </a:rPr>
+              <a:t>            question=question,</a:t>
+            </a:r>
+          </a:p>
+          <a:p>
+            <a:r>
+              <a:rPr sz="1100">
+                <a:latin typeface="Consolas"/>
+              </a:rPr>
+              <a:t>            sql=sql_raw,</a:t>
+            </a:r>
+          </a:p>
+          <a:p>
+            <a:r>
+              <a:rPr sz="1100">
+                <a:latin typeface="Consolas"/>
+              </a:rPr>
+              <a:t>            rows=[],</a:t>
+            </a:r>
+          </a:p>
+          <a:p>
+            <a:r>
+              <a:rPr sz="1100">
+                <a:latin typeface="Consolas"/>
+              </a:rPr>
+              <a:t>            answer=f"I rejected the generated SQL: {validation.reason}",</a:t>
+            </a:r>
+          </a:p>
+          <a:p>
+            <a:r>
+              <a:rPr sz="1100">
+                <a:latin typeface="Consolas"/>
+              </a:rPr>
+              <a:t>            provider=provider,</a:t>
+            </a:r>
+          </a:p>
+          <a:p>
+            <a:r>
+              <a:rPr sz="1100">
+                <a:latin typeface="Consolas"/>
+              </a:rPr>
+              <a:t>            used_fallback=used_fallback,</a:t>
+            </a:r>
+          </a:p>
+          <a:p>
+            <a:r>
+              <a:rPr sz="1100">
+                <a:latin typeface="Consolas"/>
+              </a:rPr>
+              <a:t>            error=validation.reason,</a:t>
+            </a:r>
+          </a:p>
+          <a:p>
+            <a:r>
+              <a:rPr sz="1100">
+                <a:latin typeface="Consolas"/>
+              </a:rPr>
+              <a:t>        )</a:t>
+            </a:r>
+          </a:p>
           <a:p/>
           <a:p>
             <a:r>
               <a:rPr sz="1100">
                 <a:latin typeface="Consolas"/>
               </a:rPr>
-              <a:t># ----------------------------- Public API -----------------------------</a:t>
-            </a:r>
-          </a:p>
-          <a:p>
-            <a:r>
-              <a:rPr sz="1100">
-                <a:latin typeface="Consolas"/>
-              </a:rPr>
-              <a:t>def answer(question: str) -&gt; AgentAnswer:</a:t>
-            </a:r>
-          </a:p>
-          <a:p>
-            <a:r>
-              <a:rPr sz="1100">
-                <a:latin typeface="Consolas"/>
-              </a:rPr>
-              <a:t>    schema = get_table_schema()</a:t>
-            </a:r>
-          </a:p>
-          <a:p>
-            <a:r>
-              <a:rPr sz="1100">
-                <a:latin typeface="Consolas"/>
-              </a:rPr>
-              <a:t>    provider = active_provider()</a:t>
-            </a:r>
-          </a:p>
-          <a:p>
-            <a:r>
-              <a:rPr sz="1100">
-                <a:latin typeface="Consolas"/>
-              </a:rPr>
-              <a:t>    used_fallback = provider == "fallback"</a:t>
-            </a:r>
-          </a:p>
-          <a:p>
-            <a:r>
-              <a:rPr sz="1100">
-                <a:latin typeface="Consolas"/>
-              </a:rPr>
-              <a:t>    sql_raw: str</a:t>
+              <a:t>    try:</a:t>
+            </a:r>
+          </a:p>
+          <a:p>
+            <a:r>
+              <a:rPr sz="1100">
+                <a:latin typeface="Consolas"/>
+              </a:rPr>
+              <a:t>        with open_connection() as conn:</a:t>
+            </a:r>
+          </a:p>
+          <a:p>
+            <a:r>
+              <a:rPr sz="1100">
+                <a:latin typeface="Consolas"/>
+              </a:rPr>
+              <a:t>            df = pd.read_sql_query(validation.sql, conn)</a:t>
+            </a:r>
+          </a:p>
+          <a:p>
+            <a:r>
+              <a:rPr sz="1100">
+                <a:latin typeface="Consolas"/>
+              </a:rPr>
+              <a:t>    except sqlite3.Error as e:</a:t>
+            </a:r>
+          </a:p>
+          <a:p>
+            <a:r>
+              <a:rPr sz="1100">
+                <a:latin typeface="Consolas"/>
+              </a:rPr>
+              <a:t>        return AgentAnswer(</a:t>
+            </a:r>
+          </a:p>
+          <a:p>
+            <a:r>
+              <a:rPr sz="1100">
+                <a:latin typeface="Consolas"/>
+              </a:rPr>
+              <a:t>            question=question,</a:t>
+            </a:r>
+          </a:p>
+          <a:p>
+            <a:r>
+              <a:rPr sz="1100">
+                <a:latin typeface="Consolas"/>
+              </a:rPr>
+              <a:t>            sql=validation.sql,</a:t>
+            </a:r>
+          </a:p>
+          <a:p>
+            <a:r>
+              <a:rPr sz="1100">
+                <a:latin typeface="Consolas"/>
+              </a:rPr>
+              <a:t>            rows=[],</a:t>
+            </a:r>
+          </a:p>
+          <a:p>
+            <a:r>
+              <a:rPr sz="1100">
+                <a:latin typeface="Consolas"/>
+              </a:rPr>
+              <a:t>            answer=f"SQL execution failed: {e}",</a:t>
+            </a:r>
+          </a:p>
+          <a:p>
+            <a:r>
+              <a:rPr sz="1100">
+                <a:latin typeface="Consolas"/>
+              </a:rPr>
+              <a:t>            provider=provider,</a:t>
+            </a:r>
+          </a:p>
+          <a:p>
+            <a:r>
+              <a:rPr sz="1100">
+                <a:latin typeface="Consolas"/>
+              </a:rPr>
+              <a:t>            used_fallback=used_fallback,</a:t>
+            </a:r>
+          </a:p>
+          <a:p>
+            <a:r>
+              <a:rPr sz="1100">
+                <a:latin typeface="Consolas"/>
+              </a:rPr>
+              <a:t>            error=str(e),</a:t>
+            </a:r>
+          </a:p>
+          <a:p>
+            <a:r>
+              <a:rPr sz="1100">
+                <a:latin typeface="Consolas"/>
+              </a:rPr>
+              <a:t>        )</a:t>
             </a:r>
           </a:p>
           <a:p/>
@@ -3867,305 +4113,71 @@
               <a:rPr sz="1100">
                 <a:latin typeface="Consolas"/>
               </a:rPr>
-              <a:t>    if used_fallback:</a:t>
-            </a:r>
-          </a:p>
-          <a:p>
-            <a:r>
-              <a:rPr sz="1100">
-                <a:latin typeface="Consolas"/>
-              </a:rPr>
-              <a:t>        sql_raw = _fallback_sql(question) or (</a:t>
-            </a:r>
-          </a:p>
-          <a:p>
-            <a:r>
-              <a:rPr sz="1100">
-                <a:latin typeface="Consolas"/>
-              </a:rPr>
-              <a:t>            "SELECT 'unanswerable_with_fallback_parser' AS note"</a:t>
-            </a:r>
-          </a:p>
-          <a:p>
-            <a:r>
-              <a:rPr sz="1100">
-                <a:latin typeface="Consolas"/>
-              </a:rPr>
-              <a:t>        )</a:t>
-            </a:r>
-          </a:p>
-          <a:p>
-            <a:r>
-              <a:rPr sz="1100">
-                <a:latin typeface="Consolas"/>
-              </a:rPr>
-              <a:t>    else:</a:t>
-            </a:r>
-          </a:p>
-          <a:p>
-            <a:r>
-              <a:rPr sz="1100">
-                <a:latin typeface="Consolas"/>
-              </a:rPr>
-              <a:t>        try:</a:t>
-            </a:r>
-          </a:p>
-          <a:p>
-            <a:r>
-              <a:rPr sz="1100">
-                <a:latin typeface="Consolas"/>
-              </a:rPr>
-              <a:t>            client = get_client()</a:t>
-            </a:r>
-          </a:p>
-          <a:p>
-            <a:r>
-              <a:rPr sz="1100">
-                <a:latin typeface="Consolas"/>
-              </a:rPr>
-              <a:t>            llm_text = client.chat(build_messages(schema, question))</a:t>
-            </a:r>
-          </a:p>
-          <a:p>
-            <a:r>
-              <a:rPr sz="1100">
-                <a:latin typeface="Consolas"/>
-              </a:rPr>
-              <a:t>            sql_raw = _extract_json_sql(llm_text)</a:t>
-            </a:r>
-          </a:p>
-          <a:p>
-            <a:r>
-              <a:rPr sz="1100">
-                <a:latin typeface="Consolas"/>
-              </a:rPr>
-              <a:t>        except (LLMUnavailable, Exception) as e:</a:t>
-            </a:r>
-          </a:p>
-          <a:p>
-            <a:r>
-              <a:rPr sz="1100">
-                <a:latin typeface="Consolas"/>
-              </a:rPr>
-              <a:t>            # Hard-fall-through to the deterministic parser.</a:t>
-            </a:r>
-          </a:p>
-          <a:p>
-            <a:r>
-              <a:rPr sz="1100">
-                <a:latin typeface="Consolas"/>
-              </a:rPr>
-              <a:t>            used_fallback = True</a:t>
-            </a:r>
-          </a:p>
-          <a:p>
-            <a:r>
-              <a:rPr sz="1100">
-                <a:latin typeface="Consolas"/>
-              </a:rPr>
-              <a:t>            provider = "fallback"</a:t>
-            </a:r>
-          </a:p>
-          <a:p>
-            <a:r>
-              <a:rPr sz="1100">
-                <a:latin typeface="Consolas"/>
-              </a:rPr>
-              <a:t>            sql_raw = _fallback_sql(question) or (</a:t>
-            </a:r>
-          </a:p>
-          <a:p>
-            <a:r>
-              <a:rPr sz="1100">
-                <a:latin typeface="Consolas"/>
-              </a:rPr>
-              <a:t>                "SELECT 'llm_failed_and_no_fallback_match' AS note"</a:t>
-            </a:r>
-          </a:p>
-          <a:p>
-            <a:r>
-              <a:rPr sz="1100">
-                <a:latin typeface="Consolas"/>
-              </a:rPr>
-              <a:t>            )</a:t>
-            </a:r>
-          </a:p>
-          <a:p/>
-          <a:p>
-            <a:r>
-              <a:rPr sz="1100">
-                <a:latin typeface="Consolas"/>
-              </a:rPr>
-              <a:t>    validation = validate_and_harden(sql_raw)</a:t>
-            </a:r>
-          </a:p>
-          <a:p>
-            <a:r>
-              <a:rPr sz="1100">
-                <a:latin typeface="Consolas"/>
-              </a:rPr>
-              <a:t>    if not validation.ok:</a:t>
-            </a:r>
-          </a:p>
-          <a:p>
-            <a:r>
-              <a:rPr sz="1100">
-                <a:latin typeface="Consolas"/>
-              </a:rPr>
-              <a:t>        return AgentAnswer(</a:t>
-            </a:r>
-          </a:p>
-          <a:p>
-            <a:r>
-              <a:rPr sz="1100">
-                <a:latin typeface="Consolas"/>
-              </a:rPr>
-              <a:t>            question=question,</a:t>
-            </a:r>
-          </a:p>
-          <a:p>
-            <a:r>
-              <a:rPr sz="1100">
-                <a:latin typeface="Consolas"/>
-              </a:rPr>
-              <a:t>            sql=sql_raw,</a:t>
-            </a:r>
-          </a:p>
-          <a:p>
-            <a:r>
-              <a:rPr sz="1100">
-                <a:latin typeface="Consolas"/>
-              </a:rPr>
-              <a:t>            rows=[],</a:t>
-            </a:r>
-          </a:p>
-          <a:p>
-            <a:r>
-              <a:rPr sz="1100">
-                <a:latin typeface="Consolas"/>
-              </a:rPr>
-              <a:t>            answer=f"I rejected the generated SQL: {validation.reason}",</a:t>
-            </a:r>
-          </a:p>
-          <a:p>
-            <a:r>
-              <a:rPr sz="1100">
-                <a:latin typeface="Consolas"/>
-              </a:rPr>
-              <a:t>            provider=provider,</a:t>
-            </a:r>
-          </a:p>
-          <a:p>
-            <a:r>
-              <a:rPr sz="1100">
-                <a:latin typeface="Consolas"/>
-              </a:rPr>
-              <a:t>            used_fallback=used_fallback,</a:t>
-            </a:r>
-          </a:p>
-          <a:p>
-            <a:r>
-              <a:rPr sz="1100">
-                <a:latin typeface="Consolas"/>
-              </a:rPr>
-              <a:t>            error=validation.reason,</a:t>
-            </a:r>
-          </a:p>
-          <a:p>
-            <a:r>
-              <a:rPr sz="1100">
-                <a:latin typeface="Consolas"/>
-              </a:rPr>
-              <a:t>        )</a:t>
-            </a:r>
-          </a:p>
-          <a:p/>
-          <a:p>
-            <a:r>
-              <a:rPr sz="1100">
-                <a:latin typeface="Consolas"/>
-              </a:rPr>
-              <a:t>    try:</a:t>
-            </a:r>
-          </a:p>
-          <a:p>
-            <a:r>
-              <a:rPr sz="1100">
-                <a:latin typeface="Consolas"/>
-              </a:rPr>
-              <a:t>        with open_connection() as conn:</a:t>
-            </a:r>
-          </a:p>
-          <a:p>
-            <a:r>
-              <a:rPr sz="1100">
-                <a:latin typeface="Consolas"/>
-              </a:rPr>
-              <a:t>            df = pd.read_sql_query(validation.sql, conn)</a:t>
-            </a:r>
-          </a:p>
-          <a:p>
-            <a:r>
-              <a:rPr sz="1100">
-                <a:latin typeface="Consolas"/>
-              </a:rPr>
-              <a:t>    except sqlite3.Error as e:</a:t>
-            </a:r>
-          </a:p>
-          <a:p>
-            <a:r>
-              <a:rPr sz="1100">
-                <a:latin typeface="Consolas"/>
-              </a:rPr>
-              <a:t>        return AgentAnswer(</a:t>
-            </a:r>
-          </a:p>
-          <a:p>
-            <a:r>
-              <a:rPr sz="1100">
-                <a:latin typeface="Consolas"/>
-              </a:rPr>
-              <a:t>            question=question,</a:t>
-            </a:r>
-          </a:p>
-          <a:p>
-            <a:r>
-              <a:rPr sz="1100">
-                <a:latin typeface="Consolas"/>
-              </a:rPr>
-              <a:t>            sql=validation.sql,</a:t>
-            </a:r>
-          </a:p>
-          <a:p>
-            <a:r>
-              <a:rPr sz="1100">
-                <a:latin typeface="Consolas"/>
-              </a:rPr>
-              <a:t>            rows=[],</a:t>
-            </a:r>
-          </a:p>
-          <a:p>
-            <a:r>
-              <a:rPr sz="1100">
-                <a:latin typeface="Consolas"/>
-              </a:rPr>
-              <a:t>            answer=f"SQL execution failed: {e}",</a:t>
-            </a:r>
-          </a:p>
-          <a:p>
-            <a:r>
-              <a:rPr sz="1100">
-                <a:latin typeface="Consolas"/>
-              </a:rPr>
-              <a:t>            provider=provider,</a:t>
-            </a:r>
-          </a:p>
-          <a:p>
-            <a:r>
-              <a:rPr sz="1100">
-                <a:latin typeface="Consolas"/>
-              </a:rPr>
-              <a:t>            used_fallback=used_fallback,</a:t>
+              <a:t>    summary = _summarise(question, validation.sql, df, provider)</a:t>
+            </a:r>
+          </a:p>
+          <a:p>
+            <a:r>
+              <a:rPr sz="1100">
+                <a:latin typeface="Consolas"/>
+              </a:rPr>
+              <a:t>    return AgentAnswer(</a:t>
+            </a:r>
+          </a:p>
+          <a:p>
+            <a:r>
+              <a:rPr sz="1100">
+                <a:latin typeface="Consolas"/>
+              </a:rPr>
+              <a:t>        question=question,</a:t>
+            </a:r>
+          </a:p>
+          <a:p>
+            <a:r>
+              <a:rPr sz="1100">
+                <a:latin typeface="Consolas"/>
+              </a:rPr>
+              <a:t>        sql=validation.sql,</a:t>
+            </a:r>
+          </a:p>
+          <a:p>
+            <a:r>
+              <a:rPr sz="1100">
+                <a:latin typeface="Consolas"/>
+              </a:rPr>
+              <a:t>        rows=df.to_dict(orient="records"),</a:t>
+            </a:r>
+          </a:p>
+          <a:p>
+            <a:r>
+              <a:rPr sz="1100">
+                <a:latin typeface="Consolas"/>
+              </a:rPr>
+              <a:t>        answer=summary,</a:t>
+            </a:r>
+          </a:p>
+          <a:p>
+            <a:r>
+              <a:rPr sz="1100">
+                <a:latin typeface="Consolas"/>
+              </a:rPr>
+              <a:t>        provider=provider,</a:t>
+            </a:r>
+          </a:p>
+          <a:p>
+            <a:r>
+              <a:rPr sz="1100">
+                <a:latin typeface="Consolas"/>
+              </a:rPr>
+              <a:t>        used_fallback=used_fallback,</a:t>
+            </a:r>
+          </a:p>
+          <a:p>
+            <a:r>
+              <a:rPr sz="1100">
+                <a:latin typeface="Consolas"/>
+              </a:rPr>
+              <a:t>    )</a:t>
             </a:r>
           </a:p>
         </p:txBody>
@@ -4275,55 +4287,6 @@
               <a:rPr sz="1100">
                 <a:latin typeface="Consolas"/>
               </a:rPr>
-              <a:t>import sqlparse</a:t>
-            </a:r>
-          </a:p>
-          <a:p/>
-          <a:p>
-            <a:r>
-              <a:rPr sz="1100">
-                <a:latin typeface="Consolas"/>
-              </a:rPr>
-              <a:t>ALLOWED_TABLES = {"applications"}</a:t>
-            </a:r>
-          </a:p>
-          <a:p>
-            <a:r>
-              <a:rPr sz="1100">
-                <a:latin typeface="Consolas"/>
-              </a:rPr>
-              <a:t>FORBIDDEN_PATTERNS = [</a:t>
-            </a:r>
-          </a:p>
-          <a:p>
-            <a:r>
-              <a:rPr sz="1100">
-                <a:latin typeface="Consolas"/>
-              </a:rPr>
-              <a:t>    r"\b(insert|update|delete|drop|alter|create|replace|truncate|grant|revoke)\b",</a:t>
-            </a:r>
-          </a:p>
-          <a:p>
-            <a:r>
-              <a:rPr sz="1100">
-                <a:latin typeface="Consolas"/>
-              </a:rPr>
-              <a:t>    r"\battach\b",</a:t>
-            </a:r>
-          </a:p>
-          <a:p>
-            <a:r>
-              <a:rPr sz="1100">
-                <a:latin typeface="Consolas"/>
-              </a:rPr>
-              <a:t>    r"\bdetach\b",</a:t>
-            </a:r>
-          </a:p>
-          <a:p>
-            <a:r>
-              <a:rPr sz="1100">
-                <a:latin typeface="Consolas"/>
-              </a:rPr>
               <a:t>    r"\bpragma\b",</a:t>
             </a:r>
           </a:p>
@@ -4424,7 +4387,7 @@
               <a:rPr sz="1100">
                 <a:latin typeface="Consolas"/>
               </a:rPr>
-              <a:t>def validate_and_harden(sql: str) -&gt; SqlValidation:</a:t>
+              <a:t>def validate_and_harden(sql):</a:t>
             </a:r>
           </a:p>
           <a:p>
@@ -4582,7 +4545,7 @@
               <a:rPr sz="1100">
                 <a:latin typeface="Consolas"/>
               </a:rPr>
-              <a:t>    # Collect CTE aliases (so `WITH t AS (... applications ...)` works).</a:t>
+              <a:t>    # Recognise CTE aliases so `WITH t AS (...) SELECT * FROM t` works.</a:t>
             </a:r>
           </a:p>
           <a:p>
@@ -4614,9 +4577,58 @@
               <a:rPr sz="1100">
                 <a:latin typeface="Consolas"/>
               </a:rPr>
-              <a:t>    # Reject any reference to unknown tables (cheap heuristic).</a:t>
-            </a:r>
-          </a:p>
+              <a:t>    table_refs = set(re.findall(r"\bfrom\s+([a-zA-Z_][a-zA-Z0-9_]*)", lowered))</a:t>
+            </a:r>
+          </a:p>
+          <a:p>
+            <a:r>
+              <a:rPr sz="1100">
+                <a:latin typeface="Consolas"/>
+              </a:rPr>
+              <a:t>    table_refs |= set(re.findall(r"\bjoin\s+([a-zA-Z_][a-zA-Z0-9_]*)", lowered))</a:t>
+            </a:r>
+          </a:p>
+          <a:p>
+            <a:r>
+              <a:rPr sz="1100">
+                <a:latin typeface="Consolas"/>
+              </a:rPr>
+              <a:t>    unknown = table_refs - ALLOWED_TABLES - cte_aliases</a:t>
+            </a:r>
+          </a:p>
+          <a:p>
+            <a:r>
+              <a:rPr sz="1100">
+                <a:latin typeface="Consolas"/>
+              </a:rPr>
+              <a:t>    if unknown:</a:t>
+            </a:r>
+          </a:p>
+          <a:p>
+            <a:r>
+              <a:rPr sz="1100">
+                <a:latin typeface="Consolas"/>
+              </a:rPr>
+              <a:t>        return SqlValidation(</a:t>
+            </a:r>
+          </a:p>
+          <a:p>
+            <a:r>
+              <a:rPr sz="1100">
+                <a:latin typeface="Consolas"/>
+              </a:rPr>
+              <a:t>            False, raw, f"Reference to disallowed table(s): {sorted(unknown)}"</a:t>
+            </a:r>
+          </a:p>
+          <a:p>
+            <a:r>
+              <a:rPr sz="1100">
+                <a:latin typeface="Consolas"/>
+              </a:rPr>
+              <a:t>        )</a:t>
+            </a:r>
+          </a:p>
+          <a:p/>
         </p:txBody>
       </p:sp>
     </p:spTree>
@@ -4724,7 +4736,39 @@
               <a:rPr sz="1100">
                 <a:latin typeface="Consolas"/>
               </a:rPr>
-              <a:t>    name: str = "base"</a:t>
+              <a:t>        from openai import OpenAI</a:t>
+            </a:r>
+          </a:p>
+          <a:p>
+            <a:r>
+              <a:rPr sz="1100">
+                <a:latin typeface="Consolas"/>
+              </a:rPr>
+              <a:t>        self._client = OpenAI(</a:t>
+            </a:r>
+          </a:p>
+          <a:p>
+            <a:r>
+              <a:rPr sz="1100">
+                <a:latin typeface="Consolas"/>
+              </a:rPr>
+              <a:t>            api_key=SETTINGS.openai_api_key,</a:t>
+            </a:r>
+          </a:p>
+          <a:p>
+            <a:r>
+              <a:rPr sz="1100">
+                <a:latin typeface="Consolas"/>
+              </a:rPr>
+              <a:t>            timeout=SETTINGS.llm_timeout_seconds,</a:t>
+            </a:r>
+          </a:p>
+          <a:p>
+            <a:r>
+              <a:rPr sz="1100">
+                <a:latin typeface="Consolas"/>
+              </a:rPr>
+              <a:t>        )</a:t>
             </a:r>
           </a:p>
           <a:p/>
@@ -4733,15 +4777,71 @@
               <a:rPr sz="1100">
                 <a:latin typeface="Consolas"/>
               </a:rPr>
-              <a:t>    def chat(self, messages: list[dict]) -&gt; str:</a:t>
-            </a:r>
-          </a:p>
-          <a:p>
-            <a:r>
-              <a:rPr sz="1100">
-                <a:latin typeface="Consolas"/>
-              </a:rPr>
-              <a:t>        raise NotImplementedError</a:t>
+              <a:t>    @retry(stop=stop_after_attempt(2), wait=wait_exponential_jitter(initial=1, max=4))</a:t>
+            </a:r>
+          </a:p>
+          <a:p>
+            <a:r>
+              <a:rPr sz="1100">
+                <a:latin typeface="Consolas"/>
+              </a:rPr>
+              <a:t>    def chat(self, messages):</a:t>
+            </a:r>
+          </a:p>
+          <a:p>
+            <a:r>
+              <a:rPr sz="1100">
+                <a:latin typeface="Consolas"/>
+              </a:rPr>
+              <a:t>        resp = self._client.chat.completions.create(</a:t>
+            </a:r>
+          </a:p>
+          <a:p>
+            <a:r>
+              <a:rPr sz="1100">
+                <a:latin typeface="Consolas"/>
+              </a:rPr>
+              <a:t>            model=SETTINGS.openai_model,</a:t>
+            </a:r>
+          </a:p>
+          <a:p>
+            <a:r>
+              <a:rPr sz="1100">
+                <a:latin typeface="Consolas"/>
+              </a:rPr>
+              <a:t>            messages=messages,</a:t>
+            </a:r>
+          </a:p>
+          <a:p>
+            <a:r>
+              <a:rPr sz="1100">
+                <a:latin typeface="Consolas"/>
+              </a:rPr>
+              <a:t>            temperature=SETTINGS.llm_temperature,</a:t>
+            </a:r>
+          </a:p>
+          <a:p>
+            <a:r>
+              <a:rPr sz="1100">
+                <a:latin typeface="Consolas"/>
+              </a:rPr>
+              <a:t>            max_tokens=SETTINGS.llm_max_tokens,</a:t>
+            </a:r>
+          </a:p>
+          <a:p>
+            <a:r>
+              <a:rPr sz="1100">
+                <a:latin typeface="Consolas"/>
+              </a:rPr>
+              <a:t>        )</a:t>
+            </a:r>
+          </a:p>
+          <a:p>
+            <a:r>
+              <a:rPr sz="1100">
+                <a:latin typeface="Consolas"/>
+              </a:rPr>
+              <a:t>        return (resp.choices[0].message.content or "").strip()</a:t>
             </a:r>
           </a:p>
           <a:p/>
@@ -4751,15 +4851,15 @@
               <a:rPr sz="1100">
                 <a:latin typeface="Consolas"/>
               </a:rPr>
-              <a:t>class _OpenAIClient(_BaseClient):</a:t>
-            </a:r>
-          </a:p>
-          <a:p>
-            <a:r>
-              <a:rPr sz="1100">
-                <a:latin typeface="Consolas"/>
-              </a:rPr>
-              <a:t>    name = "openai"</a:t>
+              <a:t>class _GroqClient(_BaseClient):</a:t>
+            </a:r>
+          </a:p>
+          <a:p>
+            <a:r>
+              <a:rPr sz="1100">
+                <a:latin typeface="Consolas"/>
+              </a:rPr>
+              <a:t>    name = "groq"</a:t>
             </a:r>
           </a:p>
           <a:p/>
@@ -4768,31 +4868,31 @@
               <a:rPr sz="1100">
                 <a:latin typeface="Consolas"/>
               </a:rPr>
-              <a:t>    def __init__(self) -&gt; None:</a:t>
-            </a:r>
-          </a:p>
-          <a:p>
-            <a:r>
-              <a:rPr sz="1100">
-                <a:latin typeface="Consolas"/>
-              </a:rPr>
-              <a:t>        from openai import OpenAI</a:t>
-            </a:r>
-          </a:p>
-          <a:p>
-            <a:r>
-              <a:rPr sz="1100">
-                <a:latin typeface="Consolas"/>
-              </a:rPr>
-              <a:t>        self._client = OpenAI(</a:t>
-            </a:r>
-          </a:p>
-          <a:p>
-            <a:r>
-              <a:rPr sz="1100">
-                <a:latin typeface="Consolas"/>
-              </a:rPr>
-              <a:t>            api_key=SETTINGS.openai_api_key,</a:t>
+              <a:t>    def __init__(self):</a:t>
+            </a:r>
+          </a:p>
+          <a:p>
+            <a:r>
+              <a:rPr sz="1100">
+                <a:latin typeface="Consolas"/>
+              </a:rPr>
+              <a:t>        from groq import Groq</a:t>
+            </a:r>
+          </a:p>
+          <a:p>
+            <a:r>
+              <a:rPr sz="1100">
+                <a:latin typeface="Consolas"/>
+              </a:rPr>
+              <a:t>        self._client = Groq(</a:t>
+            </a:r>
+          </a:p>
+          <a:p>
+            <a:r>
+              <a:rPr sz="1100">
+                <a:latin typeface="Consolas"/>
+              </a:rPr>
+              <a:t>            api_key=SETTINGS.groq_api_key,</a:t>
             </a:r>
           </a:p>
           <a:p>
@@ -4825,7 +4925,7 @@
               <a:rPr sz="1100">
                 <a:latin typeface="Consolas"/>
               </a:rPr>
-              <a:t>    def chat(self, messages: list[dict]) -&gt; str:</a:t>
+              <a:t>    def chat(self, messages):</a:t>
             </a:r>
           </a:p>
           <a:p>
@@ -4841,7 +4941,7 @@
               <a:rPr sz="1100">
                 <a:latin typeface="Consolas"/>
               </a:rPr>
-              <a:t>            model=SETTINGS.openai_model,</a:t>
+              <a:t>            model=SETTINGS.groq_model,</a:t>
             </a:r>
           </a:p>
           <a:p>
@@ -4891,15 +4991,15 @@
               <a:rPr sz="1100">
                 <a:latin typeface="Consolas"/>
               </a:rPr>
-              <a:t>class _GroqClient(_BaseClient):</a:t>
-            </a:r>
-          </a:p>
-          <a:p>
-            <a:r>
-              <a:rPr sz="1100">
-                <a:latin typeface="Consolas"/>
-              </a:rPr>
-              <a:t>    name = "groq"</a:t>
+              <a:t>class _GeminiClient(_BaseClient):</a:t>
+            </a:r>
+          </a:p>
+          <a:p>
+            <a:r>
+              <a:rPr sz="1100">
+                <a:latin typeface="Consolas"/>
+              </a:rPr>
+              <a:t>    name = "gemini"</a:t>
             </a:r>
           </a:p>
           <a:p/>
@@ -4908,39 +5008,128 @@
               <a:rPr sz="1100">
                 <a:latin typeface="Consolas"/>
               </a:rPr>
-              <a:t>    def __init__(self) -&gt; None:</a:t>
-            </a:r>
-          </a:p>
-          <a:p>
-            <a:r>
-              <a:rPr sz="1100">
-                <a:latin typeface="Consolas"/>
-              </a:rPr>
-              <a:t>        from groq import Groq</a:t>
-            </a:r>
-          </a:p>
-          <a:p>
-            <a:r>
-              <a:rPr sz="1100">
-                <a:latin typeface="Consolas"/>
-              </a:rPr>
-              <a:t>        self._client = Groq(</a:t>
-            </a:r>
-          </a:p>
-          <a:p>
-            <a:r>
-              <a:rPr sz="1100">
-                <a:latin typeface="Consolas"/>
-              </a:rPr>
-              <a:t>            api_key=SETTINGS.groq_api_key,</a:t>
-            </a:r>
-          </a:p>
-          <a:p>
-            <a:r>
-              <a:rPr sz="1100">
-                <a:latin typeface="Consolas"/>
-              </a:rPr>
-              <a:t>            timeout=SETTINGS.llm_timeout_seconds,</a:t>
+              <a:t>    def __init__(self):</a:t>
+            </a:r>
+          </a:p>
+          <a:p>
+            <a:r>
+              <a:rPr sz="1100">
+                <a:latin typeface="Consolas"/>
+              </a:rPr>
+              <a:t>        import google.generativeai as genai</a:t>
+            </a:r>
+          </a:p>
+          <a:p>
+            <a:r>
+              <a:rPr sz="1100">
+                <a:latin typeface="Consolas"/>
+              </a:rPr>
+              <a:t>        genai.configure(api_key=SETTINGS.gemini_api_key)</a:t>
+            </a:r>
+          </a:p>
+          <a:p>
+            <a:r>
+              <a:rPr sz="1100">
+                <a:latin typeface="Consolas"/>
+              </a:rPr>
+              <a:t>        self._model = genai.GenerativeModel(SETTINGS.gemini_model)</a:t>
+            </a:r>
+          </a:p>
+          <a:p/>
+          <a:p>
+            <a:r>
+              <a:rPr sz="1100">
+                <a:latin typeface="Consolas"/>
+              </a:rPr>
+              <a:t>    @retry(stop=stop_after_attempt(2), wait=wait_exponential_jitter(initial=1, max=4))</a:t>
+            </a:r>
+          </a:p>
+          <a:p>
+            <a:r>
+              <a:rPr sz="1100">
+                <a:latin typeface="Consolas"/>
+              </a:rPr>
+              <a:t>    def chat(self, messages):</a:t>
+            </a:r>
+          </a:p>
+          <a:p>
+            <a:r>
+              <a:rPr sz="1100">
+                <a:latin typeface="Consolas"/>
+              </a:rPr>
+              <a:t>        # Gemini has no system role - merge into the user prompt.</a:t>
+            </a:r>
+          </a:p>
+          <a:p>
+            <a:r>
+              <a:rPr sz="1100">
+                <a:latin typeface="Consolas"/>
+              </a:rPr>
+              <a:t>        sys_parts = [m["content"] for m in messages if m["role"] == "system"]</a:t>
+            </a:r>
+          </a:p>
+          <a:p>
+            <a:r>
+              <a:rPr sz="1100">
+                <a:latin typeface="Consolas"/>
+              </a:rPr>
+              <a:t>        usr_parts = [m["content"] for m in messages if m["role"] != "system"]</a:t>
+            </a:r>
+          </a:p>
+          <a:p>
+            <a:r>
+              <a:rPr sz="1100">
+                <a:latin typeface="Consolas"/>
+              </a:rPr>
+              <a:t>        prompt = ("\n\n".join(sys_parts) + "\n\n" + "\n\n".join(usr_parts)).strip()</a:t>
+            </a:r>
+          </a:p>
+          <a:p>
+            <a:r>
+              <a:rPr sz="1100">
+                <a:latin typeface="Consolas"/>
+              </a:rPr>
+              <a:t>        resp = self._model.generate_content(</a:t>
+            </a:r>
+          </a:p>
+          <a:p>
+            <a:r>
+              <a:rPr sz="1100">
+                <a:latin typeface="Consolas"/>
+              </a:rPr>
+              <a:t>            prompt,</a:t>
+            </a:r>
+          </a:p>
+          <a:p>
+            <a:r>
+              <a:rPr sz="1100">
+                <a:latin typeface="Consolas"/>
+              </a:rPr>
+              <a:t>            generation_config={</a:t>
+            </a:r>
+          </a:p>
+          <a:p>
+            <a:r>
+              <a:rPr sz="1100">
+                <a:latin typeface="Consolas"/>
+              </a:rPr>
+              <a:t>                "temperature": SETTINGS.llm_temperature,</a:t>
+            </a:r>
+          </a:p>
+          <a:p>
+            <a:r>
+              <a:rPr sz="1100">
+                <a:latin typeface="Consolas"/>
+              </a:rPr>
+              <a:t>                "max_output_tokens": SETTINGS.llm_max_tokens,</a:t>
+            </a:r>
+          </a:p>
+          <a:p>
+            <a:r>
+              <a:rPr sz="1100">
+                <a:latin typeface="Consolas"/>
+              </a:rPr>
+              <a:t>            },</a:t>
             </a:r>
           </a:p>
           <a:p>
@@ -4949,155 +5138,6 @@
                 <a:latin typeface="Consolas"/>
               </a:rPr>
               <a:t>        )</a:t>
-            </a:r>
-          </a:p>
-          <a:p/>
-          <a:p>
-            <a:r>
-              <a:rPr sz="1100">
-                <a:latin typeface="Consolas"/>
-              </a:rPr>
-              <a:t>    @retry(stop=stop_after_attempt(2), wait=wait_exponential_jitter(initial=1, max=4))</a:t>
-            </a:r>
-          </a:p>
-          <a:p>
-            <a:r>
-              <a:rPr sz="1100">
-                <a:latin typeface="Consolas"/>
-              </a:rPr>
-              <a:t>    def chat(self, messages: list[dict]) -&gt; str:</a:t>
-            </a:r>
-          </a:p>
-          <a:p>
-            <a:r>
-              <a:rPr sz="1100">
-                <a:latin typeface="Consolas"/>
-              </a:rPr>
-              <a:t>        resp = self._client.chat.completions.create(</a:t>
-            </a:r>
-          </a:p>
-          <a:p>
-            <a:r>
-              <a:rPr sz="1100">
-                <a:latin typeface="Consolas"/>
-              </a:rPr>
-              <a:t>            model=SETTINGS.groq_model,</a:t>
-            </a:r>
-          </a:p>
-          <a:p>
-            <a:r>
-              <a:rPr sz="1100">
-                <a:latin typeface="Consolas"/>
-              </a:rPr>
-              <a:t>            messages=messages,</a:t>
-            </a:r>
-          </a:p>
-          <a:p>
-            <a:r>
-              <a:rPr sz="1100">
-                <a:latin typeface="Consolas"/>
-              </a:rPr>
-              <a:t>            temperature=SETTINGS.llm_temperature,</a:t>
-            </a:r>
-          </a:p>
-          <a:p>
-            <a:r>
-              <a:rPr sz="1100">
-                <a:latin typeface="Consolas"/>
-              </a:rPr>
-              <a:t>            max_tokens=SETTINGS.llm_max_tokens,</a:t>
-            </a:r>
-          </a:p>
-          <a:p>
-            <a:r>
-              <a:rPr sz="1100">
-                <a:latin typeface="Consolas"/>
-              </a:rPr>
-              <a:t>        )</a:t>
-            </a:r>
-          </a:p>
-          <a:p>
-            <a:r>
-              <a:rPr sz="1100">
-                <a:latin typeface="Consolas"/>
-              </a:rPr>
-              <a:t>        return (resp.choices[0].message.content or "").strip()</a:t>
-            </a:r>
-          </a:p>
-          <a:p/>
-          <a:p/>
-          <a:p>
-            <a:r>
-              <a:rPr sz="1100">
-                <a:latin typeface="Consolas"/>
-              </a:rPr>
-              <a:t>class _GeminiClient(_BaseClient):</a:t>
-            </a:r>
-          </a:p>
-          <a:p>
-            <a:r>
-              <a:rPr sz="1100">
-                <a:latin typeface="Consolas"/>
-              </a:rPr>
-              <a:t>    name = "gemini"</a:t>
-            </a:r>
-          </a:p>
-          <a:p/>
-          <a:p>
-            <a:r>
-              <a:rPr sz="1100">
-                <a:latin typeface="Consolas"/>
-              </a:rPr>
-              <a:t>    def __init__(self) -&gt; None:</a:t>
-            </a:r>
-          </a:p>
-          <a:p>
-            <a:r>
-              <a:rPr sz="1100">
-                <a:latin typeface="Consolas"/>
-              </a:rPr>
-              <a:t>        import google.generativeai as genai</a:t>
-            </a:r>
-          </a:p>
-          <a:p>
-            <a:r>
-              <a:rPr sz="1100">
-                <a:latin typeface="Consolas"/>
-              </a:rPr>
-              <a:t>        genai.configure(api_key=SETTINGS.gemini_api_key)</a:t>
-            </a:r>
-          </a:p>
-          <a:p>
-            <a:r>
-              <a:rPr sz="1100">
-                <a:latin typeface="Consolas"/>
-              </a:rPr>
-              <a:t>        self._genai = genai</a:t>
-            </a:r>
-          </a:p>
-          <a:p>
-            <a:r>
-              <a:rPr sz="1100">
-                <a:latin typeface="Consolas"/>
-              </a:rPr>
-              <a:t>        self._model = genai.GenerativeModel(SETTINGS.gemini_model)</a:t>
-            </a:r>
-          </a:p>
-          <a:p/>
-          <a:p>
-            <a:r>
-              <a:rPr sz="1100">
-                <a:latin typeface="Consolas"/>
-              </a:rPr>
-              <a:t>    @retry(stop=stop_after_attempt(2), wait=wait_exponential_jitter(initial=1, max=4))</a:t>
-            </a:r>
-          </a:p>
-          <a:p>
-            <a:r>
-              <a:rPr sz="1100">
-                <a:latin typeface="Consolas"/>
-              </a:rPr>
-              <a:t>    def chat(self, messages: list[dict]) -&gt; str:</a:t>
             </a:r>
           </a:p>
         </p:txBody>

</xml_diff>